<commit_message>
Switch the CTS template to the official Seamless AV brand palette
Replace the navy house palette with the colours from the CTS brand
guidelines: base black plus the Production, Consulting and Support
division colours in light and dark variants. Covers use the three
colours as overlapping circles, the section divider is navy with a mint
number block, and the sample chart uses one series per division. README
now lists the palette with hex, RGB and Pantone values and its source.

Co-Authored-By: Claude Fable 5.1 <noreply@anthropic.com>
Claude-Session: https://claude.ai/code/session_01XrzJEmFyMntLmpxLDC4vTY
</commit_message>
<xml_diff>
--- a/presentation/CTS Presentation Template.pptx
+++ b/presentation/CTS Presentation Template.pptx
@@ -124,7 +124,7 @@
       <c:layout/>
       <c:barChart>
         <c:barDir val="col"/>
-        <c:grouping val="clustered"/>
+        <c:grouping val="stacked"/>
         <c:varyColors val="0"/>
         <c:ser>
           <c:idx val="0"/>
@@ -135,14 +135,14 @@
               <c:strCache>
                 <c:ptCount val="1"/>
                 <c:pt idx="0">
-                  <c:v>Revenue</c:v>
+                  <c:v>Production</c:v>
                 </c:pt>
               </c:strCache>
             </c:strRef>
           </c:tx>
           <c:spPr>
             <a:solidFill>
-              <a:srgbClr val="1F4E79"/>
+              <a:srgbClr val="3FD0C9"/>
             </a:solidFill>
             <a:effectLst/>
           </c:spPr>
@@ -154,17 +154,17 @@
               <a:lstStyle/>
               <a:p>
                 <a:pPr>
-                  <a:defRPr b="0" i="0" strike="noStrike" sz="900" u="none">
+                  <a:defRPr b="0" i="0" strike="noStrike" sz="1200" u="none">
                     <a:solidFill>
-                      <a:srgbClr val="595959"/>
+                      <a:srgbClr val="000000"/>
                     </a:solidFill>
-                    <a:latin typeface="Calibri"/>
+                    <a:latin typeface="Arial"/>
                   </a:defRPr>
                 </a:pPr>
               </a:p>
             </c:txPr>
             <c:showLegendKey val="0"/>
-            <c:showVal val="1"/>
+            <c:showVal val="0"/>
             <c:showCatName val="0"/>
             <c:showSerName val="0"/>
             <c:showPercent val="0"/>
@@ -224,40 +224,314 @@
                 <c:formatCode>General</c:formatCode>
                 <c:ptCount val="12"/>
                 <c:pt idx="0">
-                  <c:v>410</c:v>
+                  <c:v>210</c:v>
                 </c:pt>
                 <c:pt idx="1">
-                  <c:v>425</c:v>
+                  <c:v>225</c:v>
                 </c:pt>
                 <c:pt idx="2">
-                  <c:v>380</c:v>
+                  <c:v>180</c:v>
                 </c:pt>
                 <c:pt idx="3">
+                  <c:v>160</c:v>
+                </c:pt>
+                <c:pt idx="4">
+                  <c:v>240</c:v>
+                </c:pt>
+                <c:pt idx="5">
+                  <c:v>270</c:v>
+                </c:pt>
+                <c:pt idx="6">
+                  <c:v>255</c:v>
+                </c:pt>
+                <c:pt idx="7">
+                  <c:v>290</c:v>
+                </c:pt>
+                <c:pt idx="8">
+                  <c:v>320</c:v>
+                </c:pt>
+                <c:pt idx="9">
+                  <c:v>305</c:v>
+                </c:pt>
+                <c:pt idx="10">
+                  <c:v>330</c:v>
+                </c:pt>
+                <c:pt idx="11">
                   <c:v>360</c:v>
                 </c:pt>
+              </c:numCache>
+            </c:numRef>
+          </c:val>
+        </c:ser>
+        <c:ser>
+          <c:idx val="1"/>
+          <c:order val="1"/>
+          <c:tx>
+            <c:strRef>
+              <c:f>Sheet1!$C$1</c:f>
+              <c:strCache>
+                <c:ptCount val="1"/>
+                <c:pt idx="0">
+                  <c:v>Consulting</c:v>
+                </c:pt>
+              </c:strCache>
+            </c:strRef>
+          </c:tx>
+          <c:spPr>
+            <a:solidFill>
+              <a:srgbClr val="6D71FF"/>
+            </a:solidFill>
+            <a:effectLst/>
+          </c:spPr>
+          <c:invertIfNegative val="0"/>
+          <c:dLbls>
+            <c:numFmt formatCode="#,##0" sourceLinked="0"/>
+            <c:txPr>
+              <a:bodyPr/>
+              <a:lstStyle/>
+              <a:p>
+                <a:pPr>
+                  <a:defRPr b="0" i="0" strike="noStrike" sz="1200" u="none">
+                    <a:solidFill>
+                      <a:srgbClr val="000000"/>
+                    </a:solidFill>
+                    <a:latin typeface="Arial"/>
+                  </a:defRPr>
+                </a:pPr>
+              </a:p>
+            </c:txPr>
+            <c:showLegendKey val="0"/>
+            <c:showVal val="0"/>
+            <c:showCatName val="0"/>
+            <c:showSerName val="0"/>
+            <c:showPercent val="0"/>
+            <c:showBubbleSize val="0"/>
+            <c:showLeaderLines val="0"/>
+          </c:dLbls>
+          <c:cat>
+            <c:multiLvlStrRef>
+              <c:f>Sheet1!$A$2:$A$13</c:f>
+              <c:multiLvlStrCache>
+                <c:ptCount val="12"/>
+                <c:lvl>
+                  <c:pt idx="0">
+                    <c:v>Oct</c:v>
+                  </c:pt>
+                  <c:pt idx="1">
+                    <c:v>Nov</c:v>
+                  </c:pt>
+                  <c:pt idx="2">
+                    <c:v>Dec</c:v>
+                  </c:pt>
+                  <c:pt idx="3">
+                    <c:v>Jan</c:v>
+                  </c:pt>
+                  <c:pt idx="4">
+                    <c:v>Feb</c:v>
+                  </c:pt>
+                  <c:pt idx="5">
+                    <c:v>Mar</c:v>
+                  </c:pt>
+                  <c:pt idx="6">
+                    <c:v>Apr</c:v>
+                  </c:pt>
+                  <c:pt idx="7">
+                    <c:v>May</c:v>
+                  </c:pt>
+                  <c:pt idx="8">
+                    <c:v>Jun</c:v>
+                  </c:pt>
+                  <c:pt idx="9">
+                    <c:v>Jul</c:v>
+                  </c:pt>
+                  <c:pt idx="10">
+                    <c:v>Aug</c:v>
+                  </c:pt>
+                  <c:pt idx="11">
+                    <c:v>Sep</c:v>
+                  </c:pt>
+                </c:lvl>
+              </c:multiLvlStrCache>
+            </c:multiLvlStrRef>
+          </c:cat>
+          <c:val>
+            <c:numRef>
+              <c:f>Sheet1!$C$2:$C$13</c:f>
+              <c:numCache>
+                <c:formatCode>General</c:formatCode>
+                <c:ptCount val="12"/>
+                <c:pt idx="0">
+                  <c:v>120</c:v>
+                </c:pt>
+                <c:pt idx="1">
+                  <c:v>118</c:v>
+                </c:pt>
+                <c:pt idx="2">
+                  <c:v>125</c:v>
+                </c:pt>
+                <c:pt idx="3">
+                  <c:v>122</c:v>
+                </c:pt>
                 <c:pt idx="4">
-                  <c:v>440</c:v>
+                  <c:v>128</c:v>
                 </c:pt>
                 <c:pt idx="5">
-                  <c:v>470</c:v>
+                  <c:v>130</c:v>
                 </c:pt>
                 <c:pt idx="6">
-                  <c:v>455</c:v>
+                  <c:v>126</c:v>
                 </c:pt>
                 <c:pt idx="7">
-                  <c:v>490</c:v>
+                  <c:v>135</c:v>
                 </c:pt>
                 <c:pt idx="8">
-                  <c:v>520</c:v>
+                  <c:v>138</c:v>
                 </c:pt>
                 <c:pt idx="9">
-                  <c:v>505</c:v>
+                  <c:v>132</c:v>
                 </c:pt>
                 <c:pt idx="10">
-                  <c:v>530</c:v>
+                  <c:v>140</c:v>
                 </c:pt>
                 <c:pt idx="11">
-                  <c:v>560</c:v>
+                  <c:v>142</c:v>
+                </c:pt>
+              </c:numCache>
+            </c:numRef>
+          </c:val>
+        </c:ser>
+        <c:ser>
+          <c:idx val="2"/>
+          <c:order val="2"/>
+          <c:tx>
+            <c:strRef>
+              <c:f>Sheet1!$D$1</c:f>
+              <c:strCache>
+                <c:ptCount val="1"/>
+                <c:pt idx="0">
+                  <c:v>Support</c:v>
+                </c:pt>
+              </c:strCache>
+            </c:strRef>
+          </c:tx>
+          <c:spPr>
+            <a:solidFill>
+              <a:srgbClr val="F33844"/>
+            </a:solidFill>
+            <a:effectLst/>
+          </c:spPr>
+          <c:invertIfNegative val="0"/>
+          <c:dLbls>
+            <c:numFmt formatCode="#,##0" sourceLinked="0"/>
+            <c:txPr>
+              <a:bodyPr/>
+              <a:lstStyle/>
+              <a:p>
+                <a:pPr>
+                  <a:defRPr b="0" i="0" strike="noStrike" sz="1200" u="none">
+                    <a:solidFill>
+                      <a:srgbClr val="000000"/>
+                    </a:solidFill>
+                    <a:latin typeface="Arial"/>
+                  </a:defRPr>
+                </a:pPr>
+              </a:p>
+            </c:txPr>
+            <c:showLegendKey val="0"/>
+            <c:showVal val="0"/>
+            <c:showCatName val="0"/>
+            <c:showSerName val="0"/>
+            <c:showPercent val="0"/>
+            <c:showBubbleSize val="0"/>
+            <c:showLeaderLines val="0"/>
+          </c:dLbls>
+          <c:cat>
+            <c:multiLvlStrRef>
+              <c:f>Sheet1!$A$2:$A$13</c:f>
+              <c:multiLvlStrCache>
+                <c:ptCount val="12"/>
+                <c:lvl>
+                  <c:pt idx="0">
+                    <c:v>Oct</c:v>
+                  </c:pt>
+                  <c:pt idx="1">
+                    <c:v>Nov</c:v>
+                  </c:pt>
+                  <c:pt idx="2">
+                    <c:v>Dec</c:v>
+                  </c:pt>
+                  <c:pt idx="3">
+                    <c:v>Jan</c:v>
+                  </c:pt>
+                  <c:pt idx="4">
+                    <c:v>Feb</c:v>
+                  </c:pt>
+                  <c:pt idx="5">
+                    <c:v>Mar</c:v>
+                  </c:pt>
+                  <c:pt idx="6">
+                    <c:v>Apr</c:v>
+                  </c:pt>
+                  <c:pt idx="7">
+                    <c:v>May</c:v>
+                  </c:pt>
+                  <c:pt idx="8">
+                    <c:v>Jun</c:v>
+                  </c:pt>
+                  <c:pt idx="9">
+                    <c:v>Jul</c:v>
+                  </c:pt>
+                  <c:pt idx="10">
+                    <c:v>Aug</c:v>
+                  </c:pt>
+                  <c:pt idx="11">
+                    <c:v>Sep</c:v>
+                  </c:pt>
+                </c:lvl>
+              </c:multiLvlStrCache>
+            </c:multiLvlStrRef>
+          </c:cat>
+          <c:val>
+            <c:numRef>
+              <c:f>Sheet1!$D$2:$D$13</c:f>
+              <c:numCache>
+                <c:formatCode>General</c:formatCode>
+                <c:ptCount val="12"/>
+                <c:pt idx="0">
+                  <c:v>80</c:v>
+                </c:pt>
+                <c:pt idx="1">
+                  <c:v>82</c:v>
+                </c:pt>
+                <c:pt idx="2">
+                  <c:v>75</c:v>
+                </c:pt>
+                <c:pt idx="3">
+                  <c:v>78</c:v>
+                </c:pt>
+                <c:pt idx="4">
+                  <c:v>72</c:v>
+                </c:pt>
+                <c:pt idx="5">
+                  <c:v>70</c:v>
+                </c:pt>
+                <c:pt idx="6">
+                  <c:v>74</c:v>
+                </c:pt>
+                <c:pt idx="7">
+                  <c:v>65</c:v>
+                </c:pt>
+                <c:pt idx="8">
+                  <c:v>62</c:v>
+                </c:pt>
+                <c:pt idx="9">
+                  <c:v>68</c:v>
+                </c:pt>
+                <c:pt idx="10">
+                  <c:v>60</c:v>
+                </c:pt>
+                <c:pt idx="11">
+                  <c:v>58</c:v>
                 </c:pt>
               </c:numCache>
             </c:numRef>
@@ -270,25 +544,25 @@
             <a:lstStyle/>
             <a:p>
               <a:pPr>
-                <a:defRPr b="0" i="0" strike="noStrike" sz="900" u="none">
+                <a:defRPr b="0" i="0" strike="noStrike" sz="1200" u="none">
                   <a:solidFill>
-                    <a:srgbClr val="595959"/>
+                    <a:srgbClr val="000000"/>
                   </a:solidFill>
-                  <a:latin typeface="Calibri"/>
+                  <a:latin typeface="Arial"/>
                 </a:defRPr>
               </a:pPr>
             </a:p>
           </c:txPr>
           <c:showLegendKey val="0"/>
-          <c:showVal val="1"/>
+          <c:showVal val="0"/>
           <c:showCatName val="0"/>
           <c:showSerName val="0"/>
           <c:showPercent val="0"/>
           <c:showBubbleSize val="0"/>
           <c:showLeaderLines val="0"/>
         </c:dLbls>
-        <c:gapWidth val="150"/>
-        <c:overlap val="0"/>
+        <c:gapWidth val="50"/>
+        <c:overlap val="100"/>
         <c:axId val="2094734554"/>
         <c:axId val="2094734552"/>
         <c:axId val="2094734556"/>
@@ -318,7 +592,7 @@
             <a:pPr>
               <a:defRPr sz="1000" b="0" i="0" u="none" strike="noStrike">
                 <a:solidFill>
-                  <a:srgbClr val="595959"/>
+                  <a:srgbClr val="5F6670"/>
                 </a:solidFill>
                 <a:latin typeface="Calibri"/>
               </a:defRPr>
@@ -343,7 +617,7 @@
           <c:spPr>
             <a:ln w="6350" cap="flat">
               <a:solidFill>
-                <a:srgbClr val="E1E6EF"/>
+                <a:srgbClr val="E3E6EA"/>
               </a:solidFill>
               <a:prstDash val="solid"/>
               <a:round/>
@@ -368,7 +642,7 @@
             <a:pPr>
               <a:defRPr sz="1000" b="0" i="0" u="none" strike="noStrike">
                 <a:solidFill>
-                  <a:srgbClr val="595959"/>
+                  <a:srgbClr val="5F6670"/>
                 </a:solidFill>
                 <a:latin typeface="Calibri"/>
               </a:defRPr>
@@ -388,6 +662,26 @@
         <a:effectLst/>
       </c:spPr>
     </c:plotArea>
+    <c:legend>
+      <c:legendPos val="b"/>
+      <c:overlay val="0"/>
+      <c:txPr>
+        <a:bodyPr/>
+        <a:lstStyle/>
+        <a:p>
+          <a:pPr>
+            <a:defRPr sz="1000">
+              <a:solidFill>
+                <a:srgbClr val="5F6670"/>
+              </a:solidFill>
+              <a:latin typeface="Calibri"/>
+              <a:cs typeface="Calibri"/>
+            </a:defRPr>
+          </a:pPr>
+          <a:endParaRPr lang="en-US"/>
+        </a:p>
+      </c:txPr>
+    </c:legend>
     <c:plotVisOnly val="1"/>
     <c:dispBlanksAs val="span"/>
   </c:chart>
@@ -799,7 +1093,7 @@
           <a:p>
             <a:r>
               <a:rPr lang="en-US" dirty="0"/>
-              <a:t>Cover (dark) layout. The CTS mark on this layout is a placeholder. Replace it with the real logo file on the Slide Master (View &gt; Slide Master).</a:t>
+              <a:t>Cover (dark) layout. The CTS mark on this layout is a placeholder. Replace it with the real logo file on the Slide Master (View &gt; Slide Master). The brand guidelines say the logo is always locked up with the promise "Seamless AV".</a:t>
             </a:r>
             <a:endParaRPr lang="en-US" dirty="0"/>
           </a:p>
@@ -887,7 +1181,7 @@
           <a:p>
             <a:r>
               <a:rPr lang="en-US" dirty="0"/>
-              <a:t>Cover (light) layout. The CTS mark on this layout is a placeholder. Replace it with the real logo file on the Slide Master (View &gt; Slide Master).</a:t>
+              <a:t>Cover (light) layout. The CTS mark on this layout is a placeholder. Replace it with the real logo file on the Slide Master (View &gt; Slide Master). The brand guidelines say the logo is always locked up with the promise "Seamless AV".</a:t>
             </a:r>
             <a:endParaRPr lang="en-US" dirty="0"/>
           </a:p>
@@ -1151,7 +1445,7 @@
           <a:p>
             <a:r>
               <a:rPr lang="en-US" dirty="0"/>
-              <a:t>Header only layout. Delete the sample chart and drop in your own chart, table or image. Chart values are illustrative only.</a:t>
+              <a:t>Header only layout. Delete the sample chart and drop in your own chart, table or image. Chart values are illustrative only. Division colours: Production mint, Consulting lavender, Support rose.</a:t>
             </a:r>
             <a:endParaRPr lang="en-US" dirty="0"/>
           </a:p>
@@ -1493,7 +1787,7 @@
     <p:bg>
       <p:bgPr>
         <a:solidFill>
-          <a:srgbClr val="1F4E79"/>
+          <a:srgbClr val="121820"/>
         </a:solidFill>
       </p:bgPr>
     </p:bg>
@@ -1519,20 +1813,20 @@
         </p:nvSpPr>
         <p:spPr>
           <a:xfrm>
-            <a:off x="6766560" y="-1371600"/>
-            <a:ext cx="3840480" cy="3840480"/>
+            <a:off x="6309360" y="-548640"/>
+            <a:ext cx="3447288" cy="3447288"/>
           </a:xfrm>
           <a:prstGeom prst="ellipse">
             <a:avLst/>
           </a:prstGeom>
           <a:solidFill>
-            <a:srgbClr val="2E74B5">
-              <a:alpha val="35000"/>
+            <a:srgbClr val="3FD0C9">
+              <a:alpha val="85000"/>
             </a:srgbClr>
           </a:solidFill>
           <a:ln w="12700">
             <a:solidFill>
-              <a:srgbClr val="2E74B5">
+              <a:srgbClr val="3FD0C9">
                 <a:alpha val="0"/>
               </a:srgbClr>
             </a:solidFill>
@@ -1548,20 +1842,20 @@
         </p:nvSpPr>
         <p:spPr>
           <a:xfrm>
-            <a:off x="7406640" y="3566160"/>
-            <a:ext cx="3108960" cy="3108960"/>
+            <a:off x="8099298" y="777240"/>
+            <a:ext cx="3447288" cy="3447288"/>
           </a:xfrm>
           <a:prstGeom prst="ellipse">
             <a:avLst/>
           </a:prstGeom>
           <a:solidFill>
-            <a:srgbClr val="2E74B5">
-              <a:alpha val="22000"/>
+            <a:srgbClr val="6D71FF">
+              <a:alpha val="75000"/>
             </a:srgbClr>
           </a:solidFill>
           <a:ln w="12700">
             <a:solidFill>
-              <a:srgbClr val="2E74B5">
+              <a:srgbClr val="6D71FF">
                 <a:alpha val="0"/>
               </a:srgbClr>
             </a:solidFill>
@@ -1577,13 +1871,40 @@
         </p:nvSpPr>
         <p:spPr>
           <a:xfrm>
+            <a:off x="6773418" y="2235708"/>
+            <a:ext cx="3447288" cy="3447288"/>
+          </a:xfrm>
+          <a:prstGeom prst="ellipse">
+            <a:avLst/>
+          </a:prstGeom>
+          <a:solidFill>
+            <a:srgbClr val="F33844">
+              <a:alpha val="70000"/>
+            </a:srgbClr>
+          </a:solidFill>
+          <a:ln w="12700">
+            <a:solidFill>
+              <a:srgbClr val="F33844">
+                <a:alpha val="0"/>
+              </a:srgbClr>
+            </a:solidFill>
+            <a:prstDash val="solid"/>
+          </a:ln>
+        </p:spPr>
+      </p:sp>
+      <p:sp>
+        <p:nvSpPr>
+          <p:cNvPr id="5" name="Shape 3"/>
+          <p:cNvSpPr/>
+          <p:nvPr/>
+        </p:nvSpPr>
+        <p:spPr>
+          <a:xfrm>
             <a:off x="502920" y="411480"/>
             <a:ext cx="457200" cy="457200"/>
           </a:xfrm>
           <a:prstGeom prst="rect">
-            <a:avLst>
-              <a:gd name="adj" fmla="val 20000"/>
-            </a:avLst>
+            <a:avLst/>
           </a:prstGeom>
           <a:solidFill>
             <a:srgbClr val="FFFFFF"/>
@@ -1598,7 +1919,7 @@
       </p:sp>
       <p:sp>
         <p:nvSpPr>
-          <p:cNvPr id="5" name="Text 3"/>
+          <p:cNvPr id="6" name="Text 4"/>
           <p:cNvSpPr/>
           <p:nvPr/>
         </p:nvSpPr>
@@ -1623,7 +1944,7 @@
             <a:r>
               <a:rPr lang="en-US" sz="1300" b="1" spc="100" kern="0" dirty="0">
                 <a:solidFill>
-                  <a:srgbClr val="1F4E79"/>
+                  <a:srgbClr val="121820"/>
                 </a:solidFill>
                 <a:latin typeface="Calibri" pitchFamily="34" charset="0"/>
                 <a:ea typeface="Calibri" pitchFamily="34" charset="-122"/>
@@ -1637,14 +1958,14 @@
       </p:sp>
       <p:sp>
         <p:nvSpPr>
-          <p:cNvPr id="6" name="Text 4"/>
+          <p:cNvPr id="7" name="Text 5"/>
           <p:cNvSpPr/>
           <p:nvPr/>
         </p:nvSpPr>
         <p:spPr>
           <a:xfrm>
-            <a:off x="1097280" y="411480"/>
-            <a:ext cx="3840480" cy="457200"/>
+            <a:off x="1097280" y="393192"/>
+            <a:ext cx="3840480" cy="251460"/>
           </a:xfrm>
           <a:prstGeom prst="rect">
             <a:avLst/>
@@ -1653,14 +1974,14 @@
           <a:ln/>
         </p:spPr>
         <p:txBody>
-          <a:bodyPr wrap="square" lIns="0" tIns="0" rIns="0" bIns="0" rtlCol="0" anchor="ctr"/>
+          <a:bodyPr wrap="square" lIns="0" tIns="0" rIns="0" bIns="0" rtlCol="0" anchor="b"/>
           <a:lstStyle/>
           <a:p>
             <a:pPr indent="0" marL="0">
               <a:buNone/>
             </a:pPr>
             <a:r>
-              <a:rPr lang="en-US" sz="1300" b="1" dirty="0">
+              <a:rPr lang="en-US" sz="1200" b="1" dirty="0">
                 <a:solidFill>
                   <a:srgbClr val="FFFFFF"/>
                 </a:solidFill>
@@ -1670,22 +1991,61 @@
               </a:rPr>
               <a:t>Corporate Technology Services</a:t>
             </a:r>
-            <a:endParaRPr lang="en-US" sz="1300" dirty="0"/>
-          </a:p>
-        </p:txBody>
-      </p:sp>
-      <p:sp>
-        <p:nvSpPr>
-          <p:cNvPr id="7" name="Text 5"/>
-          <p:cNvSpPr/>
-          <p:nvPr>
-            <p:ph idx="105" type="body" hasCustomPrompt="1"/>
+            <a:endParaRPr lang="en-US" sz="1200" dirty="0"/>
+          </a:p>
+        </p:txBody>
+      </p:sp>
+      <p:sp>
+        <p:nvSpPr>
+          <p:cNvPr id="8" name="Text 6"/>
+          <p:cNvSpPr/>
+          <p:nvPr/>
+        </p:nvSpPr>
+        <p:spPr>
+          <a:xfrm>
+            <a:off x="1097280" y="653796"/>
+            <a:ext cx="3840480" cy="214884"/>
+          </a:xfrm>
+          <a:prstGeom prst="rect">
+            <a:avLst/>
+          </a:prstGeom>
+          <a:noFill/>
+          <a:ln/>
+        </p:spPr>
+        <p:txBody>
+          <a:bodyPr wrap="square" lIns="0" tIns="0" rIns="0" bIns="0" rtlCol="0" anchor="t"/>
+          <a:lstStyle/>
+          <a:p>
+            <a:pPr indent="0" marL="0">
+              <a:buNone/>
+            </a:pPr>
+            <a:r>
+              <a:rPr lang="en-US" sz="1000" dirty="0">
+                <a:solidFill>
+                  <a:srgbClr val="C9CED6"/>
+                </a:solidFill>
+                <a:latin typeface="Calibri" pitchFamily="34" charset="0"/>
+                <a:ea typeface="Calibri" pitchFamily="34" charset="-122"/>
+                <a:cs typeface="Calibri" pitchFamily="34" charset="-120"/>
+              </a:rPr>
+              <a:t>Seamless AV</a:t>
+            </a:r>
+            <a:endParaRPr lang="en-US" sz="1000" dirty="0"/>
+          </a:p>
+        </p:txBody>
+      </p:sp>
+      <p:sp>
+        <p:nvSpPr>
+          <p:cNvPr id="9" name="Text 7"/>
+          <p:cNvSpPr/>
+          <p:nvPr>
+            <p:ph idx="107" type="body" hasCustomPrompt="1"/>
           </p:nvPr>
         </p:nvSpPr>
         <p:spPr>
           <a:xfrm>
             <a:off x="502920" y="1828800"/>
-            <a:ext cx="6400800" cy="320040"/>
+            <a:ext cx="5669280" cy="320040"/>
           </a:xfrm>
           <a:prstGeom prst="rect">
             <a:avLst/>
@@ -1700,7 +2060,7 @@
               <a:buNone/>
               <a:defRPr lang="en-US" sz="1200" b="1" spc="300" kern="0" dirty="0">
                 <a:solidFill>
-                  <a:srgbClr val="D9E2F3"/>
+                  <a:srgbClr val="3FD0C9"/>
                 </a:solidFill>
                 <a:latin typeface="Calibri" pitchFamily="34" charset="0"/>
                 <a:ea typeface="Calibri" pitchFamily="34" charset="-122"/>
@@ -1715,7 +2075,7 @@
             <a:r>
               <a:rPr lang="en-US" sz="1200" b="1" spc="300" kern="0" dirty="0">
                 <a:solidFill>
-                  <a:srgbClr val="D9E2F3"/>
+                  <a:srgbClr val="3FD0C9"/>
                 </a:solidFill>
                 <a:latin typeface="Calibri" pitchFamily="34" charset="0"/>
                 <a:ea typeface="Calibri" pitchFamily="34" charset="-122"/>
@@ -1729,16 +2089,16 @@
       </p:sp>
       <p:sp>
         <p:nvSpPr>
-          <p:cNvPr id="8" name="Text 5"/>
-          <p:cNvSpPr/>
-          <p:nvPr>
-            <p:ph idx="106" type="title" hasCustomPrompt="1"/>
+          <p:cNvPr id="10" name="Text 7"/>
+          <p:cNvSpPr/>
+          <p:nvPr>
+            <p:ph idx="108" type="title" hasCustomPrompt="1"/>
           </p:nvPr>
         </p:nvSpPr>
         <p:spPr>
           <a:xfrm>
             <a:off x="502920" y="2148840"/>
-            <a:ext cx="6583680" cy="1234440"/>
+            <a:ext cx="5669280" cy="1234440"/>
           </a:xfrm>
           <a:prstGeom prst="rect">
             <a:avLst/>
@@ -1782,16 +2142,16 @@
       </p:sp>
       <p:sp>
         <p:nvSpPr>
-          <p:cNvPr id="9" name="Text 5"/>
-          <p:cNvSpPr/>
-          <p:nvPr>
-            <p:ph idx="107" type="body" hasCustomPrompt="1"/>
+          <p:cNvPr id="11" name="Text 7"/>
+          <p:cNvSpPr/>
+          <p:nvPr>
+            <p:ph idx="109" type="body" hasCustomPrompt="1"/>
           </p:nvPr>
         </p:nvSpPr>
         <p:spPr>
           <a:xfrm>
             <a:off x="502920" y="3383280"/>
-            <a:ext cx="6583680" cy="548640"/>
+            <a:ext cx="5669280" cy="548640"/>
           </a:xfrm>
           <a:prstGeom prst="rect">
             <a:avLst/>
@@ -1806,7 +2166,7 @@
               <a:buNone/>
               <a:defRPr lang="en-US" sz="1800" dirty="0">
                 <a:solidFill>
-                  <a:srgbClr val="D9E2F3"/>
+                  <a:srgbClr val="C9CED6"/>
                 </a:solidFill>
                 <a:latin typeface="Calibri" pitchFamily="34" charset="0"/>
                 <a:ea typeface="Calibri" pitchFamily="34" charset="-122"/>
@@ -1821,7 +2181,7 @@
             <a:r>
               <a:rPr lang="en-US" sz="1800" dirty="0">
                 <a:solidFill>
-                  <a:srgbClr val="D9E2F3"/>
+                  <a:srgbClr val="C9CED6"/>
                 </a:solidFill>
                 <a:latin typeface="Calibri" pitchFamily="34" charset="0"/>
                 <a:ea typeface="Calibri" pitchFamily="34" charset="-122"/>
@@ -1835,16 +2195,16 @@
       </p:sp>
       <p:sp>
         <p:nvSpPr>
-          <p:cNvPr id="10" name="Text 5"/>
-          <p:cNvSpPr/>
-          <p:nvPr>
-            <p:ph idx="108" type="body" hasCustomPrompt="1"/>
+          <p:cNvPr id="12" name="Text 7"/>
+          <p:cNvSpPr/>
+          <p:nvPr>
+            <p:ph idx="110" type="body" hasCustomPrompt="1"/>
           </p:nvPr>
         </p:nvSpPr>
         <p:spPr>
           <a:xfrm>
             <a:off x="502920" y="4251960"/>
-            <a:ext cx="4114800" cy="502920"/>
+            <a:ext cx="3657600" cy="502920"/>
           </a:xfrm>
           <a:prstGeom prst="rect">
             <a:avLst/>
@@ -1859,7 +2219,7 @@
               <a:buNone/>
               <a:defRPr lang="en-US" sz="1200" dirty="0">
                 <a:solidFill>
-                  <a:srgbClr val="D9E2F3"/>
+                  <a:srgbClr val="C9CED6"/>
                 </a:solidFill>
                 <a:latin typeface="Calibri" pitchFamily="34" charset="0"/>
                 <a:ea typeface="Calibri" pitchFamily="34" charset="-122"/>
@@ -1874,7 +2234,7 @@
             <a:r>
               <a:rPr lang="en-US" sz="1200" dirty="0">
                 <a:solidFill>
-                  <a:srgbClr val="D9E2F3"/>
+                  <a:srgbClr val="C9CED6"/>
                 </a:solidFill>
                 <a:latin typeface="Calibri" pitchFamily="34" charset="0"/>
                 <a:ea typeface="Calibri" pitchFamily="34" charset="-122"/>
@@ -1888,10 +2248,10 @@
       </p:sp>
       <p:sp>
         <p:nvSpPr>
-          <p:cNvPr id="11" name="Text 5"/>
-          <p:cNvSpPr/>
-          <p:nvPr>
-            <p:ph idx="109" type="body" hasCustomPrompt="1"/>
+          <p:cNvPr id="13" name="Text 7"/>
+          <p:cNvSpPr/>
+          <p:nvPr>
+            <p:ph idx="111" type="body" hasCustomPrompt="1"/>
           </p:nvPr>
         </p:nvSpPr>
         <p:spPr>
@@ -1912,7 +2272,7 @@
               <a:buNone/>
               <a:defRPr lang="en-US" sz="1200" dirty="0">
                 <a:solidFill>
-                  <a:srgbClr val="D9E2F3"/>
+                  <a:srgbClr val="C9CED6"/>
                 </a:solidFill>
                 <a:latin typeface="Calibri" pitchFamily="34" charset="0"/>
                 <a:ea typeface="Calibri" pitchFamily="34" charset="-122"/>
@@ -1927,7 +2287,7 @@
             <a:r>
               <a:rPr lang="en-US" sz="1200" dirty="0">
                 <a:solidFill>
-                  <a:srgbClr val="D9E2F3"/>
+                  <a:srgbClr val="C9CED6"/>
                 </a:solidFill>
                 <a:latin typeface="Calibri" pitchFamily="34" charset="0"/>
                 <a:ea typeface="Calibri" pitchFamily="34" charset="-122"/>
@@ -1986,11 +2346,11 @@
             <a:avLst/>
           </a:prstGeom>
           <a:solidFill>
-            <a:srgbClr val="1F4E79"/>
+            <a:srgbClr val="121820"/>
           </a:solidFill>
           <a:ln w="12700">
             <a:solidFill>
-              <a:srgbClr val="1F4E79"/>
+              <a:srgbClr val="121820"/>
             </a:solidFill>
             <a:prstDash val="solid"/>
           </a:ln>
@@ -2004,20 +2364,20 @@
         </p:nvSpPr>
         <p:spPr>
           <a:xfrm>
-            <a:off x="5394960" y="822960"/>
-            <a:ext cx="2743200" cy="2743200"/>
+            <a:off x="5943600" y="365760"/>
+            <a:ext cx="2971800" cy="2971800"/>
           </a:xfrm>
           <a:prstGeom prst="ellipse">
             <a:avLst/>
           </a:prstGeom>
           <a:solidFill>
-            <a:srgbClr val="2E74B5">
-              <a:alpha val="45000"/>
+            <a:srgbClr val="3FD0C9">
+              <a:alpha val="85000"/>
             </a:srgbClr>
           </a:solidFill>
           <a:ln w="12700">
             <a:solidFill>
-              <a:srgbClr val="2E74B5">
+              <a:srgbClr val="3FD0C9">
                 <a:alpha val="0"/>
               </a:srgbClr>
             </a:solidFill>
@@ -2033,20 +2393,20 @@
         </p:nvSpPr>
         <p:spPr>
           <a:xfrm>
-            <a:off x="7406640" y="3108960"/>
-            <a:ext cx="2560320" cy="2560320"/>
+            <a:off x="7486650" y="1508760"/>
+            <a:ext cx="2971800" cy="2971800"/>
           </a:xfrm>
           <a:prstGeom prst="ellipse">
             <a:avLst/>
           </a:prstGeom>
           <a:solidFill>
-            <a:srgbClr val="D9E2F3">
-              <a:alpha val="25000"/>
+            <a:srgbClr val="6D71FF">
+              <a:alpha val="75000"/>
             </a:srgbClr>
           </a:solidFill>
           <a:ln w="12700">
             <a:solidFill>
-              <a:srgbClr val="D9E2F3">
+              <a:srgbClr val="6D71FF">
                 <a:alpha val="0"/>
               </a:srgbClr>
             </a:solidFill>
@@ -2057,6 +2417,35 @@
       <p:sp>
         <p:nvSpPr>
           <p:cNvPr id="5" name="Shape 3"/>
+          <p:cNvSpPr/>
+          <p:nvPr/>
+        </p:nvSpPr>
+        <p:spPr>
+          <a:xfrm>
+            <a:off x="6343650" y="2766060"/>
+            <a:ext cx="2971800" cy="2971800"/>
+          </a:xfrm>
+          <a:prstGeom prst="ellipse">
+            <a:avLst/>
+          </a:prstGeom>
+          <a:solidFill>
+            <a:srgbClr val="F33844">
+              <a:alpha val="70000"/>
+            </a:srgbClr>
+          </a:solidFill>
+          <a:ln w="12700">
+            <a:solidFill>
+              <a:srgbClr val="F33844">
+                <a:alpha val="0"/>
+              </a:srgbClr>
+            </a:solidFill>
+            <a:prstDash val="solid"/>
+          </a:ln>
+        </p:spPr>
+      </p:sp>
+      <p:sp>
+        <p:nvSpPr>
+          <p:cNvPr id="6" name="Shape 4"/>
           <p:cNvSpPr/>
           <p:nvPr/>
         </p:nvSpPr>
@@ -2081,7 +2470,7 @@
       </p:sp>
       <p:sp>
         <p:nvSpPr>
-          <p:cNvPr id="6" name="Shape 4"/>
+          <p:cNvPr id="7" name="Shape 5"/>
           <p:cNvSpPr/>
           <p:nvPr/>
         </p:nvSpPr>
@@ -2091,16 +2480,14 @@
             <a:ext cx="457200" cy="457200"/>
           </a:xfrm>
           <a:prstGeom prst="rect">
-            <a:avLst>
-              <a:gd name="adj" fmla="val 20000"/>
-            </a:avLst>
+            <a:avLst/>
           </a:prstGeom>
           <a:solidFill>
-            <a:srgbClr val="1F4E79"/>
+            <a:srgbClr val="121820"/>
           </a:solidFill>
           <a:ln w="12700">
             <a:solidFill>
-              <a:srgbClr val="1F4E79"/>
+              <a:srgbClr val="121820"/>
             </a:solidFill>
             <a:prstDash val="solid"/>
           </a:ln>
@@ -2108,7 +2495,7 @@
       </p:sp>
       <p:sp>
         <p:nvSpPr>
-          <p:cNvPr id="7" name="Text 5"/>
+          <p:cNvPr id="8" name="Text 6"/>
           <p:cNvSpPr/>
           <p:nvPr/>
         </p:nvSpPr>
@@ -2147,14 +2534,14 @@
       </p:sp>
       <p:sp>
         <p:nvSpPr>
-          <p:cNvPr id="8" name="Text 6"/>
+          <p:cNvPr id="9" name="Text 7"/>
           <p:cNvSpPr/>
           <p:nvPr/>
         </p:nvSpPr>
         <p:spPr>
           <a:xfrm>
-            <a:off x="1097280" y="411480"/>
-            <a:ext cx="3840480" cy="457200"/>
+            <a:off x="1097280" y="393192"/>
+            <a:ext cx="3840480" cy="251460"/>
           </a:xfrm>
           <a:prstGeom prst="rect">
             <a:avLst/>
@@ -2163,16 +2550,16 @@
           <a:ln/>
         </p:spPr>
         <p:txBody>
-          <a:bodyPr wrap="square" lIns="0" tIns="0" rIns="0" bIns="0" rtlCol="0" anchor="ctr"/>
+          <a:bodyPr wrap="square" lIns="0" tIns="0" rIns="0" bIns="0" rtlCol="0" anchor="b"/>
           <a:lstStyle/>
           <a:p>
             <a:pPr indent="0" marL="0">
               <a:buNone/>
             </a:pPr>
             <a:r>
-              <a:rPr lang="en-US" sz="1300" b="1" dirty="0">
-                <a:solidFill>
-                  <a:srgbClr val="1F4E79"/>
+              <a:rPr lang="en-US" sz="1200" b="1" dirty="0">
+                <a:solidFill>
+                  <a:srgbClr val="121820"/>
                 </a:solidFill>
                 <a:latin typeface="Calibri" pitchFamily="34" charset="0"/>
                 <a:ea typeface="Calibri" pitchFamily="34" charset="-122"/>
@@ -2180,16 +2567,55 @@
               </a:rPr>
               <a:t>Corporate Technology Services</a:t>
             </a:r>
-            <a:endParaRPr lang="en-US" sz="1300" dirty="0"/>
-          </a:p>
-        </p:txBody>
-      </p:sp>
-      <p:sp>
-        <p:nvSpPr>
-          <p:cNvPr id="9" name="Text 7"/>
-          <p:cNvSpPr/>
-          <p:nvPr>
-            <p:ph idx="107" type="body" hasCustomPrompt="1"/>
+            <a:endParaRPr lang="en-US" sz="1200" dirty="0"/>
+          </a:p>
+        </p:txBody>
+      </p:sp>
+      <p:sp>
+        <p:nvSpPr>
+          <p:cNvPr id="10" name="Text 8"/>
+          <p:cNvSpPr/>
+          <p:nvPr/>
+        </p:nvSpPr>
+        <p:spPr>
+          <a:xfrm>
+            <a:off x="1097280" y="653796"/>
+            <a:ext cx="3840480" cy="214884"/>
+          </a:xfrm>
+          <a:prstGeom prst="rect">
+            <a:avLst/>
+          </a:prstGeom>
+          <a:noFill/>
+          <a:ln/>
+        </p:spPr>
+        <p:txBody>
+          <a:bodyPr wrap="square" lIns="0" tIns="0" rIns="0" bIns="0" rtlCol="0" anchor="t"/>
+          <a:lstStyle/>
+          <a:p>
+            <a:pPr indent="0" marL="0">
+              <a:buNone/>
+            </a:pPr>
+            <a:r>
+              <a:rPr lang="en-US" sz="1000" dirty="0">
+                <a:solidFill>
+                  <a:srgbClr val="5F6670"/>
+                </a:solidFill>
+                <a:latin typeface="Calibri" pitchFamily="34" charset="0"/>
+                <a:ea typeface="Calibri" pitchFamily="34" charset="-122"/>
+                <a:cs typeface="Calibri" pitchFamily="34" charset="-120"/>
+              </a:rPr>
+              <a:t>Seamless AV</a:t>
+            </a:r>
+            <a:endParaRPr lang="en-US" sz="1000" dirty="0"/>
+          </a:p>
+        </p:txBody>
+      </p:sp>
+      <p:sp>
+        <p:nvSpPr>
+          <p:cNvPr id="11" name="Text 9"/>
+          <p:cNvSpPr/>
+          <p:nvPr>
+            <p:ph idx="109" type="body" hasCustomPrompt="1"/>
           </p:nvPr>
         </p:nvSpPr>
         <p:spPr>
@@ -2210,7 +2636,7 @@
               <a:buNone/>
               <a:defRPr lang="en-US" sz="1200" b="1" spc="300" kern="0" dirty="0">
                 <a:solidFill>
-                  <a:srgbClr val="2E74B5"/>
+                  <a:srgbClr val="122B82"/>
                 </a:solidFill>
                 <a:latin typeface="Calibri" pitchFamily="34" charset="0"/>
                 <a:ea typeface="Calibri" pitchFamily="34" charset="-122"/>
@@ -2225,7 +2651,7 @@
             <a:r>
               <a:rPr lang="en-US" sz="1200" b="1" spc="300" kern="0" dirty="0">
                 <a:solidFill>
-                  <a:srgbClr val="2E74B5"/>
+                  <a:srgbClr val="122B82"/>
                 </a:solidFill>
                 <a:latin typeface="Calibri" pitchFamily="34" charset="0"/>
                 <a:ea typeface="Calibri" pitchFamily="34" charset="-122"/>
@@ -2239,10 +2665,10 @@
       </p:sp>
       <p:sp>
         <p:nvSpPr>
-          <p:cNvPr id="10" name="Text 7"/>
-          <p:cNvSpPr/>
-          <p:nvPr>
-            <p:ph idx="108" type="title" hasCustomPrompt="1"/>
+          <p:cNvPr id="12" name="Text 9"/>
+          <p:cNvSpPr/>
+          <p:nvPr>
+            <p:ph idx="110" type="title" hasCustomPrompt="1"/>
           </p:nvPr>
         </p:nvSpPr>
         <p:spPr>
@@ -2263,7 +2689,7 @@
               <a:buNone/>
               <a:defRPr lang="en-US" sz="3600" b="1" dirty="0">
                 <a:solidFill>
-                  <a:srgbClr val="1F4E79"/>
+                  <a:srgbClr val="121820"/>
                 </a:solidFill>
                 <a:latin typeface="Calibri" pitchFamily="34" charset="0"/>
                 <a:ea typeface="Calibri" pitchFamily="34" charset="-122"/>
@@ -2278,7 +2704,7 @@
             <a:r>
               <a:rPr lang="en-US" sz="3600" b="1" dirty="0">
                 <a:solidFill>
-                  <a:srgbClr val="1F4E79"/>
+                  <a:srgbClr val="121820"/>
                 </a:solidFill>
                 <a:latin typeface="Calibri" pitchFamily="34" charset="0"/>
                 <a:ea typeface="Calibri" pitchFamily="34" charset="-122"/>
@@ -2292,10 +2718,10 @@
       </p:sp>
       <p:sp>
         <p:nvSpPr>
-          <p:cNvPr id="11" name="Text 7"/>
-          <p:cNvSpPr/>
-          <p:nvPr>
-            <p:ph idx="109" type="body" hasCustomPrompt="1"/>
+          <p:cNvPr id="13" name="Text 9"/>
+          <p:cNvSpPr/>
+          <p:nvPr>
+            <p:ph idx="111" type="body" hasCustomPrompt="1"/>
           </p:nvPr>
         </p:nvSpPr>
         <p:spPr>
@@ -2316,7 +2742,7 @@
               <a:buNone/>
               <a:defRPr lang="en-US" sz="1600" dirty="0">
                 <a:solidFill>
-                  <a:srgbClr val="595959"/>
+                  <a:srgbClr val="5F6670"/>
                 </a:solidFill>
                 <a:latin typeface="Calibri" pitchFamily="34" charset="0"/>
                 <a:ea typeface="Calibri" pitchFamily="34" charset="-122"/>
@@ -2331,7 +2757,7 @@
             <a:r>
               <a:rPr lang="en-US" sz="1600" dirty="0">
                 <a:solidFill>
-                  <a:srgbClr val="595959"/>
+                  <a:srgbClr val="5F6670"/>
                 </a:solidFill>
                 <a:latin typeface="Calibri" pitchFamily="34" charset="0"/>
                 <a:ea typeface="Calibri" pitchFamily="34" charset="-122"/>
@@ -2345,10 +2771,10 @@
       </p:sp>
       <p:sp>
         <p:nvSpPr>
-          <p:cNvPr id="12" name="Text 7"/>
-          <p:cNvSpPr/>
-          <p:nvPr>
-            <p:ph idx="110" type="body" hasCustomPrompt="1"/>
+          <p:cNvPr id="14" name="Text 9"/>
+          <p:cNvSpPr/>
+          <p:nvPr>
+            <p:ph idx="112" type="body" hasCustomPrompt="1"/>
           </p:nvPr>
         </p:nvSpPr>
         <p:spPr>
@@ -2369,7 +2795,7 @@
               <a:buNone/>
               <a:defRPr lang="en-US" sz="1200" dirty="0">
                 <a:solidFill>
-                  <a:srgbClr val="595959"/>
+                  <a:srgbClr val="5F6670"/>
                 </a:solidFill>
                 <a:latin typeface="Calibri" pitchFamily="34" charset="0"/>
                 <a:ea typeface="Calibri" pitchFamily="34" charset="-122"/>
@@ -2384,7 +2810,7 @@
             <a:r>
               <a:rPr lang="en-US" sz="1200" dirty="0">
                 <a:solidFill>
-                  <a:srgbClr val="595959"/>
+                  <a:srgbClr val="5F6670"/>
                 </a:solidFill>
                 <a:latin typeface="Calibri" pitchFamily="34" charset="0"/>
                 <a:ea typeface="Calibri" pitchFamily="34" charset="-122"/>
@@ -2398,10 +2824,10 @@
       </p:sp>
       <p:sp>
         <p:nvSpPr>
-          <p:cNvPr id="13" name="Text 7"/>
-          <p:cNvSpPr/>
-          <p:nvPr>
-            <p:ph idx="111" type="body" hasCustomPrompt="1"/>
+          <p:cNvPr id="15" name="Text 9"/>
+          <p:cNvSpPr/>
+          <p:nvPr>
+            <p:ph idx="113" type="body" hasCustomPrompt="1"/>
           </p:nvPr>
         </p:nvSpPr>
         <p:spPr>
@@ -2422,7 +2848,7 @@
               <a:buNone/>
               <a:defRPr lang="en-US" sz="1200" dirty="0">
                 <a:solidFill>
-                  <a:srgbClr val="595959"/>
+                  <a:srgbClr val="5F6670"/>
                 </a:solidFill>
                 <a:latin typeface="Calibri" pitchFamily="34" charset="0"/>
                 <a:ea typeface="Calibri" pitchFamily="34" charset="-122"/>
@@ -2437,7 +2863,7 @@
             <a:r>
               <a:rPr lang="en-US" sz="1200" dirty="0">
                 <a:solidFill>
-                  <a:srgbClr val="595959"/>
+                  <a:srgbClr val="5F6670"/>
                 </a:solidFill>
                 <a:latin typeface="Calibri" pitchFamily="34" charset="0"/>
                 <a:ea typeface="Calibri" pitchFamily="34" charset="-122"/>
@@ -2463,7 +2889,7 @@
     <p:bg>
       <p:bgPr>
         <a:solidFill>
-          <a:srgbClr val="D9E2F3"/>
+          <a:srgbClr val="122B82"/>
         </a:solidFill>
       </p:bgPr>
     </p:bg>
@@ -2489,20 +2915,20 @@
         </p:nvSpPr>
         <p:spPr>
           <a:xfrm>
-            <a:off x="6675120" y="2377440"/>
-            <a:ext cx="4023360" cy="4023360"/>
+            <a:off x="6400800" y="2194560"/>
+            <a:ext cx="4206240" cy="4206240"/>
           </a:xfrm>
           <a:prstGeom prst="ellipse">
             <a:avLst/>
           </a:prstGeom>
           <a:solidFill>
-            <a:srgbClr val="FFFFFF">
-              <a:alpha val="60000"/>
+            <a:srgbClr val="6D71FF">
+              <a:alpha val="45000"/>
             </a:srgbClr>
           </a:solidFill>
           <a:ln w="12700">
             <a:solidFill>
-              <a:srgbClr val="FFFFFF">
+              <a:srgbClr val="6D71FF">
                 <a:alpha val="0"/>
               </a:srgbClr>
             </a:solidFill>
@@ -2537,7 +2963,7 @@
             <a:r>
               <a:rPr lang="en-US" sz="1100" b="1" spc="300" kern="0" dirty="0">
                 <a:solidFill>
-                  <a:srgbClr val="2E74B5"/>
+                  <a:srgbClr val="3FD0C9"/>
                 </a:solidFill>
                 <a:latin typeface="Calibri" pitchFamily="34" charset="0"/>
                 <a:ea typeface="Calibri" pitchFamily="34" charset="-122"/>
@@ -2561,16 +2987,14 @@
             <a:ext cx="384048" cy="384048"/>
           </a:xfrm>
           <a:prstGeom prst="rect">
-            <a:avLst>
-              <a:gd name="adj" fmla="val 20000"/>
-            </a:avLst>
+            <a:avLst/>
           </a:prstGeom>
           <a:solidFill>
-            <a:srgbClr val="1F4E79"/>
+            <a:srgbClr val="FFFFFF"/>
           </a:solidFill>
           <a:ln w="12700">
             <a:solidFill>
-              <a:srgbClr val="1F4E79"/>
+              <a:srgbClr val="FFFFFF"/>
             </a:solidFill>
             <a:prstDash val="solid"/>
           </a:ln>
@@ -2603,7 +3027,7 @@
             <a:r>
               <a:rPr lang="en-US" sz="1092" b="1" spc="100" kern="0" dirty="0">
                 <a:solidFill>
-                  <a:srgbClr val="FFFFFF"/>
+                  <a:srgbClr val="121820"/>
                 </a:solidFill>
                 <a:latin typeface="Calibri" pitchFamily="34" charset="0"/>
                 <a:ea typeface="Calibri" pitchFamily="34" charset="-122"/>
@@ -2627,16 +3051,14 @@
             <a:ext cx="1280160" cy="1280160"/>
           </a:xfrm>
           <a:prstGeom prst="rect">
-            <a:avLst>
-              <a:gd name="adj" fmla="val 20000"/>
-            </a:avLst>
+            <a:avLst/>
           </a:prstGeom>
           <a:solidFill>
-            <a:srgbClr val="1F4E79"/>
+            <a:srgbClr val="3FD0C9"/>
           </a:solidFill>
           <a:ln w="12700">
             <a:solidFill>
-              <a:srgbClr val="1F4E79"/>
+              <a:srgbClr val="3FD0C9"/>
             </a:solidFill>
             <a:prstDash val="solid"/>
           </a:ln>
@@ -2668,7 +3090,7 @@
               <a:buNone/>
               <a:defRPr lang="en-US" sz="4800" b="1" dirty="0">
                 <a:solidFill>
-                  <a:srgbClr val="FFFFFF"/>
+                  <a:srgbClr val="121820"/>
                 </a:solidFill>
                 <a:latin typeface="Calibri" pitchFamily="34" charset="0"/>
                 <a:ea typeface="Calibri" pitchFamily="34" charset="-122"/>
@@ -2683,7 +3105,7 @@
             <a:r>
               <a:rPr lang="en-US" sz="4800" b="1" dirty="0">
                 <a:solidFill>
-                  <a:srgbClr val="FFFFFF"/>
+                  <a:srgbClr val="121820"/>
                 </a:solidFill>
                 <a:latin typeface="Calibri" pitchFamily="34" charset="0"/>
                 <a:ea typeface="Calibri" pitchFamily="34" charset="-122"/>
@@ -2721,7 +3143,7 @@
               <a:buNone/>
               <a:defRPr lang="en-US" sz="3600" b="1" dirty="0">
                 <a:solidFill>
-                  <a:srgbClr val="1F4E79"/>
+                  <a:srgbClr val="FFFFFF"/>
                 </a:solidFill>
                 <a:latin typeface="Calibri" pitchFamily="34" charset="0"/>
                 <a:ea typeface="Calibri" pitchFamily="34" charset="-122"/>
@@ -2736,7 +3158,7 @@
             <a:r>
               <a:rPr lang="en-US" sz="3600" b="1" dirty="0">
                 <a:solidFill>
-                  <a:srgbClr val="1F4E79"/>
+                  <a:srgbClr val="FFFFFF"/>
                 </a:solidFill>
                 <a:latin typeface="Calibri" pitchFamily="34" charset="0"/>
                 <a:ea typeface="Calibri" pitchFamily="34" charset="-122"/>
@@ -2774,7 +3196,7 @@
               <a:buNone/>
               <a:defRPr lang="en-US" sz="1600" dirty="0">
                 <a:solidFill>
-                  <a:srgbClr val="595959"/>
+                  <a:srgbClr val="C9CED6"/>
                 </a:solidFill>
                 <a:latin typeface="Calibri" pitchFamily="34" charset="0"/>
                 <a:ea typeface="Calibri" pitchFamily="34" charset="-122"/>
@@ -2789,7 +3211,7 @@
             <a:r>
               <a:rPr lang="en-US" sz="1600" dirty="0">
                 <a:solidFill>
-                  <a:srgbClr val="595959"/>
+                  <a:srgbClr val="C9CED6"/>
                 </a:solidFill>
                 <a:latin typeface="Calibri" pitchFamily="34" charset="0"/>
                 <a:ea typeface="Calibri" pitchFamily="34" charset="-122"/>
@@ -2810,7 +3232,7 @@
         <p:spPr>
           <a:xfrm>
             <a:off x="502920" y="4759452"/>
-            <a:ext cx="3657600" cy="228600"/>
+            <a:ext cx="4114800" cy="228600"/>
           </a:xfrm>
           <a:prstGeom prst="rect">
             <a:avLst/>
@@ -2828,13 +3250,13 @@
             <a:r>
               <a:rPr lang="en-US" sz="900" dirty="0">
                 <a:solidFill>
-                  <a:srgbClr val="595959"/>
-                </a:solidFill>
-                <a:latin typeface="Calibri" pitchFamily="34" charset="0"/>
-                <a:ea typeface="Calibri" pitchFamily="34" charset="-122"/>
-                <a:cs typeface="Calibri" pitchFamily="34" charset="-120"/>
-              </a:rPr>
-              <a:t>Corporate Technology Services</a:t>
+                  <a:srgbClr val="C9CED6"/>
+                </a:solidFill>
+                <a:latin typeface="Calibri" pitchFamily="34" charset="0"/>
+                <a:ea typeface="Calibri" pitchFamily="34" charset="-122"/>
+                <a:cs typeface="Calibri" pitchFamily="34" charset="-120"/>
+              </a:rPr>
+              <a:t>Corporate Technology Services  |  Seamless AV</a:t>
             </a:r>
             <a:endParaRPr lang="en-US" sz="900" dirty="0"/>
           </a:p>
@@ -2870,7 +3292,7 @@
             <a:lvl1pPr>
               <a:defRPr sz="900">
                 <a:solidFill>
-                  <a:srgbClr val="595959"/>
+                  <a:srgbClr val="C9CED6"/>
                 </a:solidFill>
                 <a:latin typeface="Calibri"/>
                 <a:ea typeface="Calibri"/>
@@ -2946,7 +3368,7 @@
               <a:buNone/>
               <a:defRPr lang="en-US" sz="1000" b="1" spc="300" kern="0" dirty="0">
                 <a:solidFill>
-                  <a:srgbClr val="2E74B5"/>
+                  <a:srgbClr val="122B82"/>
                 </a:solidFill>
                 <a:latin typeface="Calibri" pitchFamily="34" charset="0"/>
                 <a:ea typeface="Calibri" pitchFamily="34" charset="-122"/>
@@ -2961,7 +3383,7 @@
             <a:r>
               <a:rPr lang="en-US" sz="1000" b="1" spc="300" kern="0" dirty="0">
                 <a:solidFill>
-                  <a:srgbClr val="2E74B5"/>
+                  <a:srgbClr val="122B82"/>
                 </a:solidFill>
                 <a:latin typeface="Calibri" pitchFamily="34" charset="0"/>
                 <a:ea typeface="Calibri" pitchFamily="34" charset="-122"/>
@@ -2999,7 +3421,7 @@
               <a:buNone/>
               <a:defRPr lang="en-US" sz="2800" b="1" dirty="0">
                 <a:solidFill>
-                  <a:srgbClr val="1F4E79"/>
+                  <a:srgbClr val="121820"/>
                 </a:solidFill>
                 <a:latin typeface="Calibri" pitchFamily="34" charset="0"/>
                 <a:ea typeface="Calibri" pitchFamily="34" charset="-122"/>
@@ -3014,7 +3436,7 @@
             <a:r>
               <a:rPr lang="en-US" sz="2800" b="1" dirty="0">
                 <a:solidFill>
-                  <a:srgbClr val="1F4E79"/>
+                  <a:srgbClr val="121820"/>
                 </a:solidFill>
                 <a:latin typeface="Calibri" pitchFamily="34" charset="0"/>
                 <a:ea typeface="Calibri" pitchFamily="34" charset="-122"/>
@@ -3038,16 +3460,14 @@
             <a:ext cx="384048" cy="384048"/>
           </a:xfrm>
           <a:prstGeom prst="rect">
-            <a:avLst>
-              <a:gd name="adj" fmla="val 20000"/>
-            </a:avLst>
+            <a:avLst/>
           </a:prstGeom>
           <a:solidFill>
-            <a:srgbClr val="1F4E79"/>
+            <a:srgbClr val="121820"/>
           </a:solidFill>
           <a:ln w="12700">
             <a:solidFill>
-              <a:srgbClr val="1F4E79"/>
+              <a:srgbClr val="121820"/>
             </a:solidFill>
             <a:prstDash val="solid"/>
           </a:ln>
@@ -3101,7 +3521,7 @@
         <p:spPr>
           <a:xfrm>
             <a:off x="502920" y="4759452"/>
-            <a:ext cx="3657600" cy="228600"/>
+            <a:ext cx="4114800" cy="228600"/>
           </a:xfrm>
           <a:prstGeom prst="rect">
             <a:avLst/>
@@ -3119,13 +3539,13 @@
             <a:r>
               <a:rPr lang="en-US" sz="900" dirty="0">
                 <a:solidFill>
-                  <a:srgbClr val="595959"/>
-                </a:solidFill>
-                <a:latin typeface="Calibri" pitchFamily="34" charset="0"/>
-                <a:ea typeface="Calibri" pitchFamily="34" charset="-122"/>
-                <a:cs typeface="Calibri" pitchFamily="34" charset="-120"/>
-              </a:rPr>
-              <a:t>Corporate Technology Services</a:t>
+                  <a:srgbClr val="5F6670"/>
+                </a:solidFill>
+                <a:latin typeface="Calibri" pitchFamily="34" charset="0"/>
+                <a:ea typeface="Calibri" pitchFamily="34" charset="-122"/>
+                <a:cs typeface="Calibri" pitchFamily="34" charset="-120"/>
+              </a:rPr>
+              <a:t>Corporate Technology Services  |  Seamless AV</a:t>
             </a:r>
             <a:endParaRPr lang="en-US" sz="900" dirty="0"/>
           </a:p>
@@ -3161,7 +3581,7 @@
             <a:lvl1pPr>
               <a:defRPr sz="900">
                 <a:solidFill>
-                  <a:srgbClr val="595959"/>
+                  <a:srgbClr val="5F6670"/>
                 </a:solidFill>
                 <a:latin typeface="Calibri"/>
                 <a:ea typeface="Calibri"/>
@@ -3237,7 +3657,7 @@
               <a:buNone/>
               <a:defRPr lang="en-US" sz="1000" b="1" spc="300" kern="0" dirty="0">
                 <a:solidFill>
-                  <a:srgbClr val="2E74B5"/>
+                  <a:srgbClr val="122B82"/>
                 </a:solidFill>
                 <a:latin typeface="Calibri" pitchFamily="34" charset="0"/>
                 <a:ea typeface="Calibri" pitchFamily="34" charset="-122"/>
@@ -3252,7 +3672,7 @@
             <a:r>
               <a:rPr lang="en-US" sz="1000" b="1" spc="300" kern="0" dirty="0">
                 <a:solidFill>
-                  <a:srgbClr val="2E74B5"/>
+                  <a:srgbClr val="122B82"/>
                 </a:solidFill>
                 <a:latin typeface="Calibri" pitchFamily="34" charset="0"/>
                 <a:ea typeface="Calibri" pitchFamily="34" charset="-122"/>
@@ -3290,7 +3710,7 @@
               <a:buNone/>
               <a:defRPr lang="en-US" sz="2800" b="1" dirty="0">
                 <a:solidFill>
-                  <a:srgbClr val="1F4E79"/>
+                  <a:srgbClr val="121820"/>
                 </a:solidFill>
                 <a:latin typeface="Calibri" pitchFamily="34" charset="0"/>
                 <a:ea typeface="Calibri" pitchFamily="34" charset="-122"/>
@@ -3305,7 +3725,7 @@
             <a:r>
               <a:rPr lang="en-US" sz="2800" b="1" dirty="0">
                 <a:solidFill>
-                  <a:srgbClr val="1F4E79"/>
+                  <a:srgbClr val="121820"/>
                 </a:solidFill>
                 <a:latin typeface="Calibri" pitchFamily="34" charset="0"/>
                 <a:ea typeface="Calibri" pitchFamily="34" charset="-122"/>
@@ -3329,16 +3749,14 @@
             <a:ext cx="384048" cy="384048"/>
           </a:xfrm>
           <a:prstGeom prst="rect">
-            <a:avLst>
-              <a:gd name="adj" fmla="val 20000"/>
-            </a:avLst>
+            <a:avLst/>
           </a:prstGeom>
           <a:solidFill>
-            <a:srgbClr val="1F4E79"/>
+            <a:srgbClr val="121820"/>
           </a:solidFill>
           <a:ln w="12700">
             <a:solidFill>
-              <a:srgbClr val="1F4E79"/>
+              <a:srgbClr val="121820"/>
             </a:solidFill>
             <a:prstDash val="solid"/>
           </a:ln>
@@ -3392,7 +3810,7 @@
         <p:spPr>
           <a:xfrm>
             <a:off x="502920" y="4759452"/>
-            <a:ext cx="3657600" cy="228600"/>
+            <a:ext cx="4114800" cy="228600"/>
           </a:xfrm>
           <a:prstGeom prst="rect">
             <a:avLst/>
@@ -3410,13 +3828,13 @@
             <a:r>
               <a:rPr lang="en-US" sz="900" dirty="0">
                 <a:solidFill>
-                  <a:srgbClr val="595959"/>
-                </a:solidFill>
-                <a:latin typeface="Calibri" pitchFamily="34" charset="0"/>
-                <a:ea typeface="Calibri" pitchFamily="34" charset="-122"/>
-                <a:cs typeface="Calibri" pitchFamily="34" charset="-120"/>
-              </a:rPr>
-              <a:t>Corporate Technology Services</a:t>
+                  <a:srgbClr val="5F6670"/>
+                </a:solidFill>
+                <a:latin typeface="Calibri" pitchFamily="34" charset="0"/>
+                <a:ea typeface="Calibri" pitchFamily="34" charset="-122"/>
+                <a:cs typeface="Calibri" pitchFamily="34" charset="-120"/>
+              </a:rPr>
+              <a:t>Corporate Technology Services  |  Seamless AV</a:t>
             </a:r>
             <a:endParaRPr lang="en-US" sz="900" dirty="0"/>
           </a:p>
@@ -3452,7 +3870,7 @@
               <a:buChar char="•"/>
               <a:defRPr lang="en-US" sz="1600" dirty="0">
                 <a:solidFill>
-                  <a:srgbClr val="262626"/>
+                  <a:srgbClr val="121820"/>
                 </a:solidFill>
                 <a:latin typeface="Calibri" pitchFamily="34" charset="0"/>
                 <a:ea typeface="Calibri" pitchFamily="34" charset="-122"/>
@@ -3471,7 +3889,7 @@
             <a:r>
               <a:rPr lang="en-US" sz="1600" dirty="0">
                 <a:solidFill>
-                  <a:srgbClr val="262626"/>
+                  <a:srgbClr val="121820"/>
                 </a:solidFill>
                 <a:latin typeface="Calibri" pitchFamily="34" charset="0"/>
                 <a:ea typeface="Calibri" pitchFamily="34" charset="-122"/>
@@ -3513,7 +3931,7 @@
             <a:lvl1pPr>
               <a:defRPr sz="900">
                 <a:solidFill>
-                  <a:srgbClr val="595959"/>
+                  <a:srgbClr val="5F6670"/>
                 </a:solidFill>
                 <a:latin typeface="Calibri"/>
                 <a:ea typeface="Calibri"/>
@@ -3586,7 +4004,7 @@
             <a:lvl1pPr>
               <a:defRPr sz="900">
                 <a:solidFill>
-                  <a:srgbClr val="595959"/>
+                  <a:srgbClr val="C9CED6"/>
                 </a:solidFill>
                 <a:latin typeface="Calibri"/>
                 <a:ea typeface="Calibri"/>
@@ -3888,16 +4306,16 @@
       </p:grpSpPr>
       <p:sp>
         <p:nvSpPr>
-          <p:cNvPr id="2" name="Text 5"/>
-          <p:cNvSpPr/>
-          <p:nvPr>
-            <p:ph idx="105" type="body" hasCustomPrompt="1"/>
+          <p:cNvPr id="2" name="Text 7"/>
+          <p:cNvSpPr/>
+          <p:nvPr>
+            <p:ph idx="107" type="body" hasCustomPrompt="1"/>
           </p:nvPr>
         </p:nvSpPr>
         <p:spPr>
           <a:xfrm>
             <a:off x="502920" y="1828800"/>
-            <a:ext cx="6400800" cy="320040"/>
+            <a:ext cx="5669280" cy="320040"/>
           </a:xfrm>
           <a:prstGeom prst="rect">
             <a:avLst/>
@@ -3915,7 +4333,7 @@
             <a:r>
               <a:rPr lang="en-US" sz="1200" b="1" spc="300" kern="0" dirty="0">
                 <a:solidFill>
-                  <a:srgbClr val="D9E2F3"/>
+                  <a:srgbClr val="3FD0C9"/>
                 </a:solidFill>
                 <a:latin typeface="Calibri" pitchFamily="34" charset="0"/>
                 <a:ea typeface="Calibri" pitchFamily="34" charset="-122"/>
@@ -3929,16 +4347,16 @@
       </p:sp>
       <p:sp>
         <p:nvSpPr>
-          <p:cNvPr id="3" name="Text 5"/>
-          <p:cNvSpPr/>
-          <p:nvPr>
-            <p:ph idx="106" type="title" hasCustomPrompt="1"/>
+          <p:cNvPr id="3" name="Text 7"/>
+          <p:cNvSpPr/>
+          <p:nvPr>
+            <p:ph idx="108" type="title" hasCustomPrompt="1"/>
           </p:nvPr>
         </p:nvSpPr>
         <p:spPr>
           <a:xfrm>
             <a:off x="502920" y="2148840"/>
-            <a:ext cx="6583680" cy="1234440"/>
+            <a:ext cx="5669280" cy="1234440"/>
           </a:xfrm>
           <a:prstGeom prst="rect">
             <a:avLst/>
@@ -3970,16 +4388,16 @@
       </p:sp>
       <p:sp>
         <p:nvSpPr>
-          <p:cNvPr id="4" name="Text 5"/>
-          <p:cNvSpPr/>
-          <p:nvPr>
-            <p:ph idx="107" type="body" hasCustomPrompt="1"/>
+          <p:cNvPr id="4" name="Text 7"/>
+          <p:cNvSpPr/>
+          <p:nvPr>
+            <p:ph idx="109" type="body" hasCustomPrompt="1"/>
           </p:nvPr>
         </p:nvSpPr>
         <p:spPr>
           <a:xfrm>
             <a:off x="502920" y="3383280"/>
-            <a:ext cx="6583680" cy="548640"/>
+            <a:ext cx="5669280" cy="548640"/>
           </a:xfrm>
           <a:prstGeom prst="rect">
             <a:avLst/>
@@ -3997,7 +4415,7 @@
             <a:r>
               <a:rPr lang="en-US" sz="1800" dirty="0">
                 <a:solidFill>
-                  <a:srgbClr val="D9E2F3"/>
+                  <a:srgbClr val="C9CED6"/>
                 </a:solidFill>
                 <a:latin typeface="Calibri" pitchFamily="34" charset="0"/>
                 <a:ea typeface="Calibri" pitchFamily="34" charset="-122"/>
@@ -4011,16 +4429,16 @@
       </p:sp>
       <p:sp>
         <p:nvSpPr>
-          <p:cNvPr id="5" name="Text 5"/>
-          <p:cNvSpPr/>
-          <p:nvPr>
-            <p:ph idx="108" type="body" hasCustomPrompt="1"/>
+          <p:cNvPr id="5" name="Text 7"/>
+          <p:cNvSpPr/>
+          <p:nvPr>
+            <p:ph idx="110" type="body" hasCustomPrompt="1"/>
           </p:nvPr>
         </p:nvSpPr>
         <p:spPr>
           <a:xfrm>
             <a:off x="502920" y="4251960"/>
-            <a:ext cx="4114800" cy="502920"/>
+            <a:ext cx="3657600" cy="502920"/>
           </a:xfrm>
           <a:prstGeom prst="rect">
             <a:avLst/>
@@ -4038,7 +4456,7 @@
             <a:r>
               <a:rPr lang="en-US" sz="1200" dirty="0">
                 <a:solidFill>
-                  <a:srgbClr val="D9E2F3"/>
+                  <a:srgbClr val="C9CED6"/>
                 </a:solidFill>
                 <a:latin typeface="Calibri" pitchFamily="34" charset="0"/>
                 <a:ea typeface="Calibri" pitchFamily="34" charset="-122"/>
@@ -4052,10 +4470,10 @@
       </p:sp>
       <p:sp>
         <p:nvSpPr>
-          <p:cNvPr id="6" name="Text 5"/>
-          <p:cNvSpPr/>
-          <p:nvPr>
-            <p:ph idx="109" type="body" hasCustomPrompt="1"/>
+          <p:cNvPr id="6" name="Text 7"/>
+          <p:cNvSpPr/>
+          <p:nvPr>
+            <p:ph idx="111" type="body" hasCustomPrompt="1"/>
           </p:nvPr>
         </p:nvSpPr>
         <p:spPr>
@@ -4079,7 +4497,7 @@
             <a:r>
               <a:rPr lang="en-US" sz="1200" dirty="0">
                 <a:solidFill>
-                  <a:srgbClr val="D9E2F3"/>
+                  <a:srgbClr val="C9CED6"/>
                 </a:solidFill>
                 <a:latin typeface="Calibri" pitchFamily="34" charset="0"/>
                 <a:ea typeface="Calibri" pitchFamily="34" charset="-122"/>
@@ -4118,10 +4536,10 @@
       </p:grpSpPr>
       <p:sp>
         <p:nvSpPr>
-          <p:cNvPr id="2" name="Text 7"/>
-          <p:cNvSpPr/>
-          <p:nvPr>
-            <p:ph idx="107" type="body" hasCustomPrompt="1"/>
+          <p:cNvPr id="2" name="Text 9"/>
+          <p:cNvSpPr/>
+          <p:nvPr>
+            <p:ph idx="109" type="body" hasCustomPrompt="1"/>
           </p:nvPr>
         </p:nvSpPr>
         <p:spPr>
@@ -4145,7 +4563,7 @@
             <a:r>
               <a:rPr lang="en-US" sz="1200" b="1" spc="300" kern="0" dirty="0">
                 <a:solidFill>
-                  <a:srgbClr val="2E74B5"/>
+                  <a:srgbClr val="122B82"/>
                 </a:solidFill>
                 <a:latin typeface="Calibri" pitchFamily="34" charset="0"/>
                 <a:ea typeface="Calibri" pitchFamily="34" charset="-122"/>
@@ -4159,10 +4577,10 @@
       </p:sp>
       <p:sp>
         <p:nvSpPr>
-          <p:cNvPr id="3" name="Text 7"/>
-          <p:cNvSpPr/>
-          <p:nvPr>
-            <p:ph idx="108" type="title" hasCustomPrompt="1"/>
+          <p:cNvPr id="3" name="Text 9"/>
+          <p:cNvSpPr/>
+          <p:nvPr>
+            <p:ph idx="110" type="title" hasCustomPrompt="1"/>
           </p:nvPr>
         </p:nvSpPr>
         <p:spPr>
@@ -4186,7 +4604,7 @@
             <a:r>
               <a:rPr lang="en-US" sz="3600" b="1" dirty="0">
                 <a:solidFill>
-                  <a:srgbClr val="1F4E79"/>
+                  <a:srgbClr val="121820"/>
                 </a:solidFill>
                 <a:latin typeface="Calibri" pitchFamily="34" charset="0"/>
                 <a:ea typeface="Calibri" pitchFamily="34" charset="-122"/>
@@ -4200,10 +4618,10 @@
       </p:sp>
       <p:sp>
         <p:nvSpPr>
-          <p:cNvPr id="4" name="Text 7"/>
-          <p:cNvSpPr/>
-          <p:nvPr>
-            <p:ph idx="109" type="body" hasCustomPrompt="1"/>
+          <p:cNvPr id="4" name="Text 9"/>
+          <p:cNvSpPr/>
+          <p:nvPr>
+            <p:ph idx="111" type="body" hasCustomPrompt="1"/>
           </p:nvPr>
         </p:nvSpPr>
         <p:spPr>
@@ -4227,7 +4645,7 @@
             <a:r>
               <a:rPr lang="en-US" sz="1600" dirty="0">
                 <a:solidFill>
-                  <a:srgbClr val="595959"/>
+                  <a:srgbClr val="5F6670"/>
                 </a:solidFill>
                 <a:latin typeface="Calibri" pitchFamily="34" charset="0"/>
                 <a:ea typeface="Calibri" pitchFamily="34" charset="-122"/>
@@ -4241,10 +4659,10 @@
       </p:sp>
       <p:sp>
         <p:nvSpPr>
-          <p:cNvPr id="5" name="Text 7"/>
-          <p:cNvSpPr/>
-          <p:nvPr>
-            <p:ph idx="110" type="body" hasCustomPrompt="1"/>
+          <p:cNvPr id="5" name="Text 9"/>
+          <p:cNvSpPr/>
+          <p:nvPr>
+            <p:ph idx="112" type="body" hasCustomPrompt="1"/>
           </p:nvPr>
         </p:nvSpPr>
         <p:spPr>
@@ -4268,7 +4686,7 @@
             <a:r>
               <a:rPr lang="en-US" sz="1200" dirty="0">
                 <a:solidFill>
-                  <a:srgbClr val="595959"/>
+                  <a:srgbClr val="5F6670"/>
                 </a:solidFill>
                 <a:latin typeface="Calibri" pitchFamily="34" charset="0"/>
                 <a:ea typeface="Calibri" pitchFamily="34" charset="-122"/>
@@ -4282,10 +4700,10 @@
       </p:sp>
       <p:sp>
         <p:nvSpPr>
-          <p:cNvPr id="6" name="Text 7"/>
-          <p:cNvSpPr/>
-          <p:nvPr>
-            <p:ph idx="111" type="body" hasCustomPrompt="1"/>
+          <p:cNvPr id="6" name="Text 9"/>
+          <p:cNvSpPr/>
+          <p:nvPr>
+            <p:ph idx="113" type="body" hasCustomPrompt="1"/>
           </p:nvPr>
         </p:nvSpPr>
         <p:spPr>
@@ -4309,7 +4727,7 @@
             <a:r>
               <a:rPr lang="en-US" sz="1200" dirty="0">
                 <a:solidFill>
-                  <a:srgbClr val="595959"/>
+                  <a:srgbClr val="5F6670"/>
                 </a:solidFill>
                 <a:latin typeface="Calibri" pitchFamily="34" charset="0"/>
                 <a:ea typeface="Calibri" pitchFamily="34" charset="-122"/>
@@ -4375,7 +4793,7 @@
             <a:r>
               <a:rPr lang="en-US" sz="4800" b="1" dirty="0">
                 <a:solidFill>
-                  <a:srgbClr val="FFFFFF"/>
+                  <a:srgbClr val="121820"/>
                 </a:solidFill>
                 <a:latin typeface="Calibri" pitchFamily="34" charset="0"/>
                 <a:ea typeface="Calibri" pitchFamily="34" charset="-122"/>
@@ -4416,7 +4834,7 @@
             <a:r>
               <a:rPr lang="en-US" sz="3600" b="1" dirty="0">
                 <a:solidFill>
-                  <a:srgbClr val="1F4E79"/>
+                  <a:srgbClr val="FFFFFF"/>
                 </a:solidFill>
                 <a:latin typeface="Calibri" pitchFamily="34" charset="0"/>
                 <a:ea typeface="Calibri" pitchFamily="34" charset="-122"/>
@@ -4457,7 +4875,7 @@
             <a:r>
               <a:rPr lang="en-US" sz="1600" dirty="0">
                 <a:solidFill>
-                  <a:srgbClr val="595959"/>
+                  <a:srgbClr val="C9CED6"/>
                 </a:solidFill>
                 <a:latin typeface="Calibri" pitchFamily="34" charset="0"/>
                 <a:ea typeface="Calibri" pitchFamily="34" charset="-122"/>
@@ -4499,7 +4917,7 @@
             <a:lvl1pPr>
               <a:defRPr sz="900">
                 <a:solidFill>
-                  <a:srgbClr val="595959"/>
+                  <a:srgbClr val="C9CED6"/>
                 </a:solidFill>
                 <a:latin typeface="Calibri"/>
                 <a:ea typeface="Calibri"/>
@@ -4571,7 +4989,7 @@
             <a:r>
               <a:rPr lang="en-US" sz="4800" b="1" dirty="0">
                 <a:solidFill>
-                  <a:srgbClr val="FFFFFF"/>
+                  <a:srgbClr val="121820"/>
                 </a:solidFill>
                 <a:latin typeface="Calibri" pitchFamily="34" charset="0"/>
                 <a:ea typeface="Calibri" pitchFamily="34" charset="-122"/>
@@ -4612,7 +5030,7 @@
             <a:r>
               <a:rPr lang="en-US" sz="3600" b="1" dirty="0">
                 <a:solidFill>
-                  <a:srgbClr val="1F4E79"/>
+                  <a:srgbClr val="FFFFFF"/>
                 </a:solidFill>
                 <a:latin typeface="Calibri" pitchFamily="34" charset="0"/>
                 <a:ea typeface="Calibri" pitchFamily="34" charset="-122"/>
@@ -4653,7 +5071,7 @@
             <a:r>
               <a:rPr lang="en-US" sz="1600" dirty="0">
                 <a:solidFill>
-                  <a:srgbClr val="595959"/>
+                  <a:srgbClr val="C9CED6"/>
                 </a:solidFill>
                 <a:latin typeface="Calibri" pitchFamily="34" charset="0"/>
                 <a:ea typeface="Calibri" pitchFamily="34" charset="-122"/>
@@ -4695,7 +5113,7 @@
             <a:lvl1pPr>
               <a:defRPr sz="900">
                 <a:solidFill>
-                  <a:srgbClr val="595959"/>
+                  <a:srgbClr val="C9CED6"/>
                 </a:solidFill>
                 <a:latin typeface="Calibri"/>
                 <a:ea typeface="Calibri"/>
@@ -4767,7 +5185,7 @@
             <a:r>
               <a:rPr lang="en-US" sz="1000" b="1" spc="300" kern="0" dirty="0">
                 <a:solidFill>
-                  <a:srgbClr val="2E74B5"/>
+                  <a:srgbClr val="122B82"/>
                 </a:solidFill>
                 <a:latin typeface="Calibri" pitchFamily="34" charset="0"/>
                 <a:ea typeface="Calibri" pitchFamily="34" charset="-122"/>
@@ -4808,13 +5226,13 @@
             <a:r>
               <a:rPr lang="en-US" sz="2800" b="1" dirty="0">
                 <a:solidFill>
-                  <a:srgbClr val="1F4E79"/>
-                </a:solidFill>
-                <a:latin typeface="Calibri" pitchFamily="34" charset="0"/>
-                <a:ea typeface="Calibri" pitchFamily="34" charset="-122"/>
-                <a:cs typeface="Calibri" pitchFamily="34" charset="-120"/>
-              </a:rPr>
-              <a:t>Revenue by client, rolling twelve months</a:t>
+                  <a:srgbClr val="121820"/>
+                </a:solidFill>
+                <a:latin typeface="Calibri" pitchFamily="34" charset="0"/>
+                <a:ea typeface="Calibri" pitchFamily="34" charset="-122"/>
+                <a:cs typeface="Calibri" pitchFamily="34" charset="-120"/>
+              </a:rPr>
+              <a:t>Revenue by division, rolling twelve months</a:t>
             </a:r>
             <a:endParaRPr lang="en-US" sz="2800" dirty="0"/>
           </a:p>
@@ -4866,7 +5284,7 @@
             <a:lvl1pPr>
               <a:defRPr sz="900">
                 <a:solidFill>
-                  <a:srgbClr val="595959"/>
+                  <a:srgbClr val="5F6670"/>
                 </a:solidFill>
                 <a:latin typeface="Calibri"/>
                 <a:ea typeface="Calibri"/>
@@ -4938,7 +5356,7 @@
             <a:r>
               <a:rPr lang="en-US" sz="1000" b="1" spc="300" kern="0" dirty="0">
                 <a:solidFill>
-                  <a:srgbClr val="2E74B5"/>
+                  <a:srgbClr val="122B82"/>
                 </a:solidFill>
                 <a:latin typeface="Calibri" pitchFamily="34" charset="0"/>
                 <a:ea typeface="Calibri" pitchFamily="34" charset="-122"/>
@@ -4979,7 +5397,7 @@
             <a:r>
               <a:rPr lang="en-US" sz="2800" b="1" dirty="0">
                 <a:solidFill>
-                  <a:srgbClr val="1F4E79"/>
+                  <a:srgbClr val="121820"/>
                 </a:solidFill>
                 <a:latin typeface="Calibri" pitchFamily="34" charset="0"/>
                 <a:ea typeface="Calibri" pitchFamily="34" charset="-122"/>
@@ -5021,7 +5439,7 @@
             <a:lvl1pPr>
               <a:defRPr sz="900">
                 <a:solidFill>
-                  <a:srgbClr val="595959"/>
+                  <a:srgbClr val="5F6670"/>
                 </a:solidFill>
                 <a:latin typeface="Calibri"/>
                 <a:ea typeface="Calibri"/>
@@ -5093,7 +5511,7 @@
             <a:r>
               <a:rPr lang="en-US" sz="1000" b="1" spc="300" kern="0" dirty="0">
                 <a:solidFill>
-                  <a:srgbClr val="2E74B5"/>
+                  <a:srgbClr val="122B82"/>
                 </a:solidFill>
                 <a:latin typeface="Calibri" pitchFamily="34" charset="0"/>
                 <a:ea typeface="Calibri" pitchFamily="34" charset="-122"/>
@@ -5134,7 +5552,7 @@
             <a:r>
               <a:rPr lang="en-US" sz="2800" b="1" dirty="0">
                 <a:solidFill>
-                  <a:srgbClr val="1F4E79"/>
+                  <a:srgbClr val="121820"/>
                 </a:solidFill>
                 <a:latin typeface="Calibri" pitchFamily="34" charset="0"/>
                 <a:ea typeface="Calibri" pitchFamily="34" charset="-122"/>
@@ -5179,7 +5597,7 @@
             <a:r>
               <a:rPr lang="en-US" sz="1600" dirty="0">
                 <a:solidFill>
-                  <a:srgbClr val="262626"/>
+                  <a:srgbClr val="121820"/>
                 </a:solidFill>
                 <a:latin typeface="Calibri" pitchFamily="34" charset="0"/>
                 <a:ea typeface="Calibri" pitchFamily="34" charset="-122"/>
@@ -5200,7 +5618,7 @@
             <a:r>
               <a:rPr lang="en-US" sz="1600" dirty="0">
                 <a:solidFill>
-                  <a:srgbClr val="262626"/>
+                  <a:srgbClr val="121820"/>
                 </a:solidFill>
                 <a:latin typeface="Calibri" pitchFamily="34" charset="0"/>
                 <a:ea typeface="Calibri" pitchFamily="34" charset="-122"/>
@@ -5221,7 +5639,7 @@
             <a:r>
               <a:rPr lang="en-US" sz="1600" dirty="0">
                 <a:solidFill>
-                  <a:srgbClr val="262626"/>
+                  <a:srgbClr val="121820"/>
                 </a:solidFill>
                 <a:latin typeface="Calibri" pitchFamily="34" charset="0"/>
                 <a:ea typeface="Calibri" pitchFamily="34" charset="-122"/>
@@ -5242,7 +5660,7 @@
             <a:r>
               <a:rPr lang="en-US" sz="1600" dirty="0">
                 <a:solidFill>
-                  <a:srgbClr val="262626"/>
+                  <a:srgbClr val="121820"/>
                 </a:solidFill>
                 <a:latin typeface="Calibri" pitchFamily="34" charset="0"/>
                 <a:ea typeface="Calibri" pitchFamily="34" charset="-122"/>
@@ -5284,7 +5702,7 @@
             <a:lvl1pPr>
               <a:defRPr sz="900">
                 <a:solidFill>
-                  <a:srgbClr val="595959"/>
+                  <a:srgbClr val="5F6670"/>
                 </a:solidFill>
                 <a:latin typeface="Calibri"/>
                 <a:ea typeface="Calibri"/>
@@ -5356,7 +5774,7 @@
             <a:r>
               <a:rPr lang="en-US" sz="1000" b="1" spc="300" kern="0" dirty="0">
                 <a:solidFill>
-                  <a:srgbClr val="2E74B5"/>
+                  <a:srgbClr val="122B82"/>
                 </a:solidFill>
                 <a:latin typeface="Calibri" pitchFamily="34" charset="0"/>
                 <a:ea typeface="Calibri" pitchFamily="34" charset="-122"/>
@@ -5397,7 +5815,7 @@
             <a:r>
               <a:rPr lang="en-US" sz="2800" b="1" dirty="0">
                 <a:solidFill>
-                  <a:srgbClr val="1F4E79"/>
+                  <a:srgbClr val="121820"/>
                 </a:solidFill>
                 <a:latin typeface="Calibri" pitchFamily="34" charset="0"/>
                 <a:ea typeface="Calibri" pitchFamily="34" charset="-122"/>
@@ -5439,7 +5857,7 @@
             <a:r>
               <a:rPr lang="en-US" sz="1600" dirty="0">
                 <a:solidFill>
-                  <a:srgbClr val="262626"/>
+                  <a:srgbClr val="121820"/>
                 </a:solidFill>
                 <a:latin typeface="Calibri" pitchFamily="34" charset="0"/>
                 <a:ea typeface="Calibri" pitchFamily="34" charset="-122"/>
@@ -5469,7 +5887,7 @@
             <a:r>
               <a:rPr lang="en-US" sz="1600" dirty="0">
                 <a:solidFill>
-                  <a:srgbClr val="262626"/>
+                  <a:srgbClr val="121820"/>
                 </a:solidFill>
                 <a:latin typeface="Calibri" pitchFamily="34" charset="0"/>
                 <a:ea typeface="Calibri" pitchFamily="34" charset="-122"/>
@@ -5490,7 +5908,7 @@
             <a:r>
               <a:rPr lang="en-US" sz="1600" dirty="0">
                 <a:solidFill>
-                  <a:srgbClr val="262626"/>
+                  <a:srgbClr val="121820"/>
                 </a:solidFill>
                 <a:latin typeface="Calibri" pitchFamily="34" charset="0"/>
                 <a:ea typeface="Calibri" pitchFamily="34" charset="-122"/>
@@ -5511,7 +5929,7 @@
             <a:r>
               <a:rPr lang="en-US" sz="1600" dirty="0">
                 <a:solidFill>
-                  <a:srgbClr val="262626"/>
+                  <a:srgbClr val="121820"/>
                 </a:solidFill>
                 <a:latin typeface="Calibri" pitchFamily="34" charset="0"/>
                 <a:ea typeface="Calibri" pitchFamily="34" charset="-122"/>
@@ -5534,17 +5952,15 @@
             <a:off x="5303520" y="1554480"/>
             <a:ext cx="3337560" cy="3017520"/>
           </a:xfrm>
-          <a:prstGeom prst="roundRect">
-            <a:avLst>
-              <a:gd name="adj" fmla="val 4848"/>
-            </a:avLst>
+          <a:prstGeom prst="rect">
+            <a:avLst/>
           </a:prstGeom>
           <a:solidFill>
-            <a:srgbClr val="D9E2F3"/>
+            <a:srgbClr val="E8F9F8"/>
           </a:solidFill>
           <a:ln w="12700">
             <a:solidFill>
-              <a:srgbClr val="D9E2F3"/>
+              <a:srgbClr val="E8F9F8"/>
             </a:solidFill>
             <a:prstDash val="solid"/>
           </a:ln>
@@ -5577,7 +5993,7 @@
             <a:r>
               <a:rPr lang="en-US" sz="1000" b="1" spc="200" kern="0" dirty="0">
                 <a:solidFill>
-                  <a:srgbClr val="2E74B5"/>
+                  <a:srgbClr val="005358"/>
                 </a:solidFill>
                 <a:latin typeface="Calibri" pitchFamily="34" charset="0"/>
                 <a:ea typeface="Calibri" pitchFamily="34" charset="-122"/>
@@ -5616,7 +6032,7 @@
             <a:r>
               <a:rPr lang="en-US" sz="1800" b="1" dirty="0">
                 <a:solidFill>
-                  <a:srgbClr val="1F4E79"/>
+                  <a:srgbClr val="121820"/>
                 </a:solidFill>
                 <a:latin typeface="Calibri" pitchFamily="34" charset="0"/>
                 <a:ea typeface="Calibri" pitchFamily="34" charset="-122"/>
@@ -5655,7 +6071,7 @@
             <a:r>
               <a:rPr lang="en-US" sz="1100" dirty="0">
                 <a:solidFill>
-                  <a:srgbClr val="595959"/>
+                  <a:srgbClr val="5F6670"/>
                 </a:solidFill>
                 <a:latin typeface="Calibri" pitchFamily="34" charset="0"/>
                 <a:ea typeface="Calibri" pitchFamily="34" charset="-122"/>
@@ -5731,7 +6147,7 @@
             <a:lvl1pPr>
               <a:defRPr sz="900">
                 <a:solidFill>
-                  <a:srgbClr val="595959"/>
+                  <a:srgbClr val="5F6670"/>
                 </a:solidFill>
                 <a:latin typeface="Calibri"/>
                 <a:ea typeface="Calibri"/>

</xml_diff>

<commit_message>
Let the CTS template pick up real logo files from presentation/assets
When cts-logo.png (and optionally cts-logo-dark.png) exist, the build
places them on every layout in place of the placeholder mark, scaled to
the logo height with the file's own aspect ratio.

Co-Authored-By: Claude Fable 5.1 <noreply@anthropic.com>
Claude-Session: https://claude.ai/code/session_01XrzJEmFyMntLmpxLDC4vTY
</commit_message>
<xml_diff>
--- a/presentation/CTS Presentation Template.pptx
+++ b/presentation/CTS Presentation Template.pptx
@@ -1093,7 +1093,7 @@
           <a:p>
             <a:r>
               <a:rPr lang="en-US" dirty="0"/>
-              <a:t>Cover (dark) layout. The CTS mark on this layout is a placeholder. Replace it with the real logo file on the Slide Master (View &gt; Slide Master). The brand guidelines say the logo is always locked up with the promise "Seamless AV".</a:t>
+              <a:t>Cover (dark) layout. The CTS mark on this layout is a placeholder. Drop the real logo into presentation/assets/cts-logo.png (and cts-logo-dark.png for dark slides) and rebuild, or replace it on the Slide Master (View &gt; Slide Master).</a:t>
             </a:r>
             <a:endParaRPr lang="en-US" dirty="0"/>
           </a:p>
@@ -1181,7 +1181,7 @@
           <a:p>
             <a:r>
               <a:rPr lang="en-US" dirty="0"/>
-              <a:t>Cover (light) layout. The CTS mark on this layout is a placeholder. Replace it with the real logo file on the Slide Master (View &gt; Slide Master). The brand guidelines say the logo is always locked up with the promise "Seamless AV".</a:t>
+              <a:t>Cover (light) layout. The CTS mark on this layout is a placeholder. Drop the real logo into presentation/assets/cts-logo.png (and cts-logo-dark.png for dark slides) and rebuild, or replace it on the Slide Master (View &gt; Slide Master).</a:t>
             </a:r>
             <a:endParaRPr lang="en-US" dirty="0"/>
           </a:p>

</xml_diff>

<commit_message>
Add the official CTS Seamless AV logo to every template layout
Downloads the charcoal and white logo exports and the vector wordmark
from the CTS website (current and archived), places them on all five
layouts, and stores the brand colour and strategy PDFs as source.

Co-Authored-By: Claude Fable 5.1 <noreply@anthropic.com>
Claude-Session: https://claude.ai/code/session_01XrzJEmFyMntLmpxLDC4vTY
</commit_message>
<xml_diff>
--- a/presentation/CTS Presentation Template.pptx
+++ b/presentation/CTS Presentation Template.pptx
@@ -1093,7 +1093,7 @@
           <a:p>
             <a:r>
               <a:rPr lang="en-US" dirty="0"/>
-              <a:t>Cover (dark) layout. The CTS mark on this layout is a placeholder. Drop the real logo into presentation/assets/cts-logo.png (and cts-logo-dark.png for dark slides) and rebuild, or replace it on the Slide Master (View &gt; Slide Master).</a:t>
+              <a:t>Cover (dark) layout. Logo: the official CTS Seamless AV lock-up from presentation/assets (white on dark layouts, charcoal on white).</a:t>
             </a:r>
             <a:endParaRPr lang="en-US" dirty="0"/>
           </a:p>
@@ -1181,7 +1181,7 @@
           <a:p>
             <a:r>
               <a:rPr lang="en-US" dirty="0"/>
-              <a:t>Cover (light) layout. The CTS mark on this layout is a placeholder. Drop the real logo into presentation/assets/cts-logo.png (and cts-logo-dark.png for dark slides) and rebuild, or replace it on the Slide Master (View &gt; Slide Master).</a:t>
+              <a:t>Cover (light) layout. Logo: the official CTS Seamless AV lock-up from presentation/assets (white on dark layouts, charcoal on white).</a:t>
             </a:r>
             <a:endParaRPr lang="en-US" dirty="0"/>
           </a:p>
@@ -1892,154 +1892,36 @@
           </a:ln>
         </p:spPr>
       </p:sp>
-      <p:sp>
-        <p:nvSpPr>
-          <p:cNvPr id="5" name="Shape 3"/>
+      <p:pic>
+        <p:nvPicPr>
+          <p:cNvPr id="5" name="Image 0" descr="/home/user/Claude/presentation/assets/cts-logo-dark.png">    </p:cNvPr>
+          <p:cNvPicPr>
+            <a:picLocks noChangeAspect="1"/>
+          </p:cNvPicPr>
+          <p:nvPr/>
+        </p:nvPicPr>
+        <p:blipFill>
+          <a:blip r:embed="rId1"/>
+          <a:stretch>
+            <a:fillRect/>
+          </a:stretch>
+        </p:blipFill>
+        <p:spPr>
+          <a:xfrm>
+            <a:off x="502920" y="411480"/>
+            <a:ext cx="1143440" cy="777240"/>
+          </a:xfrm>
+          <a:prstGeom prst="rect">
+            <a:avLst/>
+          </a:prstGeom>
+        </p:spPr>
+      </p:pic>
+      <p:sp>
+        <p:nvSpPr>
+          <p:cNvPr id="6" name="Text 3"/>
           <p:cNvSpPr/>
-          <p:nvPr/>
-        </p:nvSpPr>
-        <p:spPr>
-          <a:xfrm>
-            <a:off x="502920" y="411480"/>
-            <a:ext cx="457200" cy="457200"/>
-          </a:xfrm>
-          <a:prstGeom prst="rect">
-            <a:avLst/>
-          </a:prstGeom>
-          <a:solidFill>
-            <a:srgbClr val="FFFFFF"/>
-          </a:solidFill>
-          <a:ln w="12700">
-            <a:solidFill>
-              <a:srgbClr val="FFFFFF"/>
-            </a:solidFill>
-            <a:prstDash val="solid"/>
-          </a:ln>
-        </p:spPr>
-      </p:sp>
-      <p:sp>
-        <p:nvSpPr>
-          <p:cNvPr id="6" name="Text 4"/>
-          <p:cNvSpPr/>
-          <p:nvPr/>
-        </p:nvSpPr>
-        <p:spPr>
-          <a:xfrm>
-            <a:off x="502920" y="411480"/>
-            <a:ext cx="457200" cy="457200"/>
-          </a:xfrm>
-          <a:prstGeom prst="rect">
-            <a:avLst/>
-          </a:prstGeom>
-          <a:noFill/>
-          <a:ln/>
-        </p:spPr>
-        <p:txBody>
-          <a:bodyPr wrap="square" lIns="0" tIns="0" rIns="0" bIns="0" rtlCol="0" anchor="ctr"/>
-          <a:lstStyle/>
-          <a:p>
-            <a:pPr algn="ctr" indent="0" marL="0">
-              <a:buNone/>
-            </a:pPr>
-            <a:r>
-              <a:rPr lang="en-US" sz="1300" b="1" spc="100" kern="0" dirty="0">
-                <a:solidFill>
-                  <a:srgbClr val="121820"/>
-                </a:solidFill>
-                <a:latin typeface="Calibri" pitchFamily="34" charset="0"/>
-                <a:ea typeface="Calibri" pitchFamily="34" charset="-122"/>
-                <a:cs typeface="Calibri" pitchFamily="34" charset="-120"/>
-              </a:rPr>
-              <a:t>CTS</a:t>
-            </a:r>
-            <a:endParaRPr lang="en-US" sz="1300" dirty="0"/>
-          </a:p>
-        </p:txBody>
-      </p:sp>
-      <p:sp>
-        <p:nvSpPr>
-          <p:cNvPr id="7" name="Text 5"/>
-          <p:cNvSpPr/>
-          <p:nvPr/>
-        </p:nvSpPr>
-        <p:spPr>
-          <a:xfrm>
-            <a:off x="1097280" y="393192"/>
-            <a:ext cx="3840480" cy="251460"/>
-          </a:xfrm>
-          <a:prstGeom prst="rect">
-            <a:avLst/>
-          </a:prstGeom>
-          <a:noFill/>
-          <a:ln/>
-        </p:spPr>
-        <p:txBody>
-          <a:bodyPr wrap="square" lIns="0" tIns="0" rIns="0" bIns="0" rtlCol="0" anchor="b"/>
-          <a:lstStyle/>
-          <a:p>
-            <a:pPr indent="0" marL="0">
-              <a:buNone/>
-            </a:pPr>
-            <a:r>
-              <a:rPr lang="en-US" sz="1200" b="1" dirty="0">
-                <a:solidFill>
-                  <a:srgbClr val="FFFFFF"/>
-                </a:solidFill>
-                <a:latin typeface="Calibri" pitchFamily="34" charset="0"/>
-                <a:ea typeface="Calibri" pitchFamily="34" charset="-122"/>
-                <a:cs typeface="Calibri" pitchFamily="34" charset="-120"/>
-              </a:rPr>
-              <a:t>Corporate Technology Services</a:t>
-            </a:r>
-            <a:endParaRPr lang="en-US" sz="1200" dirty="0"/>
-          </a:p>
-        </p:txBody>
-      </p:sp>
-      <p:sp>
-        <p:nvSpPr>
-          <p:cNvPr id="8" name="Text 6"/>
-          <p:cNvSpPr/>
-          <p:nvPr/>
-        </p:nvSpPr>
-        <p:spPr>
-          <a:xfrm>
-            <a:off x="1097280" y="653796"/>
-            <a:ext cx="3840480" cy="214884"/>
-          </a:xfrm>
-          <a:prstGeom prst="rect">
-            <a:avLst/>
-          </a:prstGeom>
-          <a:noFill/>
-          <a:ln/>
-        </p:spPr>
-        <p:txBody>
-          <a:bodyPr wrap="square" lIns="0" tIns="0" rIns="0" bIns="0" rtlCol="0" anchor="t"/>
-          <a:lstStyle/>
-          <a:p>
-            <a:pPr indent="0" marL="0">
-              <a:buNone/>
-            </a:pPr>
-            <a:r>
-              <a:rPr lang="en-US" sz="1000" dirty="0">
-                <a:solidFill>
-                  <a:srgbClr val="C9CED6"/>
-                </a:solidFill>
-                <a:latin typeface="Calibri" pitchFamily="34" charset="0"/>
-                <a:ea typeface="Calibri" pitchFamily="34" charset="-122"/>
-                <a:cs typeface="Calibri" pitchFamily="34" charset="-120"/>
-              </a:rPr>
-              <a:t>Seamless AV</a:t>
-            </a:r>
-            <a:endParaRPr lang="en-US" sz="1000" dirty="0"/>
-          </a:p>
-        </p:txBody>
-      </p:sp>
-      <p:sp>
-        <p:nvSpPr>
-          <p:cNvPr id="9" name="Text 7"/>
-          <p:cNvSpPr/>
-          <p:nvPr>
-            <p:ph idx="107" type="body" hasCustomPrompt="1"/>
+          <p:nvPr>
+            <p:ph idx="104" type="body" hasCustomPrompt="1"/>
           </p:nvPr>
         </p:nvSpPr>
         <p:spPr>
@@ -2089,10 +1971,10 @@
       </p:sp>
       <p:sp>
         <p:nvSpPr>
-          <p:cNvPr id="10" name="Text 7"/>
+          <p:cNvPr id="7" name="Text 3"/>
           <p:cNvSpPr/>
           <p:nvPr>
-            <p:ph idx="108" type="title" hasCustomPrompt="1"/>
+            <p:ph idx="105" type="title" hasCustomPrompt="1"/>
           </p:nvPr>
         </p:nvSpPr>
         <p:spPr>
@@ -2142,10 +2024,10 @@
       </p:sp>
       <p:sp>
         <p:nvSpPr>
-          <p:cNvPr id="11" name="Text 7"/>
+          <p:cNvPr id="8" name="Text 3"/>
           <p:cNvSpPr/>
           <p:nvPr>
-            <p:ph idx="109" type="body" hasCustomPrompt="1"/>
+            <p:ph idx="106" type="body" hasCustomPrompt="1"/>
           </p:nvPr>
         </p:nvSpPr>
         <p:spPr>
@@ -2195,10 +2077,10 @@
       </p:sp>
       <p:sp>
         <p:nvSpPr>
-          <p:cNvPr id="12" name="Text 7"/>
+          <p:cNvPr id="9" name="Text 3"/>
           <p:cNvSpPr/>
           <p:nvPr>
-            <p:ph idx="110" type="body" hasCustomPrompt="1"/>
+            <p:ph idx="107" type="body" hasCustomPrompt="1"/>
           </p:nvPr>
         </p:nvSpPr>
         <p:spPr>
@@ -2248,10 +2130,10 @@
       </p:sp>
       <p:sp>
         <p:nvSpPr>
-          <p:cNvPr id="13" name="Text 7"/>
+          <p:cNvPr id="10" name="Text 3"/>
           <p:cNvSpPr/>
           <p:nvPr>
-            <p:ph idx="111" type="body" hasCustomPrompt="1"/>
+            <p:ph idx="108" type="body" hasCustomPrompt="1"/>
           </p:nvPr>
         </p:nvSpPr>
         <p:spPr>
@@ -2468,154 +2350,36 @@
           </a:ln>
         </p:spPr>
       </p:sp>
-      <p:sp>
-        <p:nvSpPr>
-          <p:cNvPr id="7" name="Shape 5"/>
+      <p:pic>
+        <p:nvPicPr>
+          <p:cNvPr id="7" name="Image 0" descr="/home/user/Claude/presentation/assets/cts-logo.png">    </p:cNvPr>
+          <p:cNvPicPr>
+            <a:picLocks noChangeAspect="1"/>
+          </p:cNvPicPr>
+          <p:nvPr/>
+        </p:nvPicPr>
+        <p:blipFill>
+          <a:blip r:embed="rId1"/>
+          <a:stretch>
+            <a:fillRect/>
+          </a:stretch>
+        </p:blipFill>
+        <p:spPr>
+          <a:xfrm>
+            <a:off x="502920" y="411480"/>
+            <a:ext cx="1143440" cy="777240"/>
+          </a:xfrm>
+          <a:prstGeom prst="rect">
+            <a:avLst/>
+          </a:prstGeom>
+        </p:spPr>
+      </p:pic>
+      <p:sp>
+        <p:nvSpPr>
+          <p:cNvPr id="8" name="Text 5"/>
           <p:cNvSpPr/>
-          <p:nvPr/>
-        </p:nvSpPr>
-        <p:spPr>
-          <a:xfrm>
-            <a:off x="502920" y="411480"/>
-            <a:ext cx="457200" cy="457200"/>
-          </a:xfrm>
-          <a:prstGeom prst="rect">
-            <a:avLst/>
-          </a:prstGeom>
-          <a:solidFill>
-            <a:srgbClr val="121820"/>
-          </a:solidFill>
-          <a:ln w="12700">
-            <a:solidFill>
-              <a:srgbClr val="121820"/>
-            </a:solidFill>
-            <a:prstDash val="solid"/>
-          </a:ln>
-        </p:spPr>
-      </p:sp>
-      <p:sp>
-        <p:nvSpPr>
-          <p:cNvPr id="8" name="Text 6"/>
-          <p:cNvSpPr/>
-          <p:nvPr/>
-        </p:nvSpPr>
-        <p:spPr>
-          <a:xfrm>
-            <a:off x="502920" y="411480"/>
-            <a:ext cx="457200" cy="457200"/>
-          </a:xfrm>
-          <a:prstGeom prst="rect">
-            <a:avLst/>
-          </a:prstGeom>
-          <a:noFill/>
-          <a:ln/>
-        </p:spPr>
-        <p:txBody>
-          <a:bodyPr wrap="square" lIns="0" tIns="0" rIns="0" bIns="0" rtlCol="0" anchor="ctr"/>
-          <a:lstStyle/>
-          <a:p>
-            <a:pPr algn="ctr" indent="0" marL="0">
-              <a:buNone/>
-            </a:pPr>
-            <a:r>
-              <a:rPr lang="en-US" sz="1300" b="1" spc="100" kern="0" dirty="0">
-                <a:solidFill>
-                  <a:srgbClr val="FFFFFF"/>
-                </a:solidFill>
-                <a:latin typeface="Calibri" pitchFamily="34" charset="0"/>
-                <a:ea typeface="Calibri" pitchFamily="34" charset="-122"/>
-                <a:cs typeface="Calibri" pitchFamily="34" charset="-120"/>
-              </a:rPr>
-              <a:t>CTS</a:t>
-            </a:r>
-            <a:endParaRPr lang="en-US" sz="1300" dirty="0"/>
-          </a:p>
-        </p:txBody>
-      </p:sp>
-      <p:sp>
-        <p:nvSpPr>
-          <p:cNvPr id="9" name="Text 7"/>
-          <p:cNvSpPr/>
-          <p:nvPr/>
-        </p:nvSpPr>
-        <p:spPr>
-          <a:xfrm>
-            <a:off x="1097280" y="393192"/>
-            <a:ext cx="3840480" cy="251460"/>
-          </a:xfrm>
-          <a:prstGeom prst="rect">
-            <a:avLst/>
-          </a:prstGeom>
-          <a:noFill/>
-          <a:ln/>
-        </p:spPr>
-        <p:txBody>
-          <a:bodyPr wrap="square" lIns="0" tIns="0" rIns="0" bIns="0" rtlCol="0" anchor="b"/>
-          <a:lstStyle/>
-          <a:p>
-            <a:pPr indent="0" marL="0">
-              <a:buNone/>
-            </a:pPr>
-            <a:r>
-              <a:rPr lang="en-US" sz="1200" b="1" dirty="0">
-                <a:solidFill>
-                  <a:srgbClr val="121820"/>
-                </a:solidFill>
-                <a:latin typeface="Calibri" pitchFamily="34" charset="0"/>
-                <a:ea typeface="Calibri" pitchFamily="34" charset="-122"/>
-                <a:cs typeface="Calibri" pitchFamily="34" charset="-120"/>
-              </a:rPr>
-              <a:t>Corporate Technology Services</a:t>
-            </a:r>
-            <a:endParaRPr lang="en-US" sz="1200" dirty="0"/>
-          </a:p>
-        </p:txBody>
-      </p:sp>
-      <p:sp>
-        <p:nvSpPr>
-          <p:cNvPr id="10" name="Text 8"/>
-          <p:cNvSpPr/>
-          <p:nvPr/>
-        </p:nvSpPr>
-        <p:spPr>
-          <a:xfrm>
-            <a:off x="1097280" y="653796"/>
-            <a:ext cx="3840480" cy="214884"/>
-          </a:xfrm>
-          <a:prstGeom prst="rect">
-            <a:avLst/>
-          </a:prstGeom>
-          <a:noFill/>
-          <a:ln/>
-        </p:spPr>
-        <p:txBody>
-          <a:bodyPr wrap="square" lIns="0" tIns="0" rIns="0" bIns="0" rtlCol="0" anchor="t"/>
-          <a:lstStyle/>
-          <a:p>
-            <a:pPr indent="0" marL="0">
-              <a:buNone/>
-            </a:pPr>
-            <a:r>
-              <a:rPr lang="en-US" sz="1000" dirty="0">
-                <a:solidFill>
-                  <a:srgbClr val="5F6670"/>
-                </a:solidFill>
-                <a:latin typeface="Calibri" pitchFamily="34" charset="0"/>
-                <a:ea typeface="Calibri" pitchFamily="34" charset="-122"/>
-                <a:cs typeface="Calibri" pitchFamily="34" charset="-120"/>
-              </a:rPr>
-              <a:t>Seamless AV</a:t>
-            </a:r>
-            <a:endParaRPr lang="en-US" sz="1000" dirty="0"/>
-          </a:p>
-        </p:txBody>
-      </p:sp>
-      <p:sp>
-        <p:nvSpPr>
-          <p:cNvPr id="11" name="Text 9"/>
-          <p:cNvSpPr/>
-          <p:nvPr>
-            <p:ph idx="109" type="body" hasCustomPrompt="1"/>
+          <p:nvPr>
+            <p:ph idx="106" type="body" hasCustomPrompt="1"/>
           </p:nvPr>
         </p:nvSpPr>
         <p:spPr>
@@ -2665,10 +2429,10 @@
       </p:sp>
       <p:sp>
         <p:nvSpPr>
-          <p:cNvPr id="12" name="Text 9"/>
+          <p:cNvPr id="9" name="Text 5"/>
           <p:cNvSpPr/>
           <p:nvPr>
-            <p:ph idx="110" type="title" hasCustomPrompt="1"/>
+            <p:ph idx="107" type="title" hasCustomPrompt="1"/>
           </p:nvPr>
         </p:nvSpPr>
         <p:spPr>
@@ -2718,10 +2482,10 @@
       </p:sp>
       <p:sp>
         <p:nvSpPr>
-          <p:cNvPr id="13" name="Text 9"/>
+          <p:cNvPr id="10" name="Text 5"/>
           <p:cNvSpPr/>
           <p:nvPr>
-            <p:ph idx="111" type="body" hasCustomPrompt="1"/>
+            <p:ph idx="108" type="body" hasCustomPrompt="1"/>
           </p:nvPr>
         </p:nvSpPr>
         <p:spPr>
@@ -2771,10 +2535,10 @@
       </p:sp>
       <p:sp>
         <p:nvSpPr>
-          <p:cNvPr id="14" name="Text 9"/>
+          <p:cNvPr id="11" name="Text 5"/>
           <p:cNvSpPr/>
           <p:nvPr>
-            <p:ph idx="112" type="body" hasCustomPrompt="1"/>
+            <p:ph idx="109" type="body" hasCustomPrompt="1"/>
           </p:nvPr>
         </p:nvSpPr>
         <p:spPr>
@@ -2824,10 +2588,10 @@
       </p:sp>
       <p:sp>
         <p:nvSpPr>
-          <p:cNvPr id="15" name="Text 9"/>
+          <p:cNvPr id="12" name="Text 5"/>
           <p:cNvSpPr/>
           <p:nvPr>
-            <p:ph idx="113" type="body" hasCustomPrompt="1"/>
+            <p:ph idx="110" type="body" hasCustomPrompt="1"/>
           </p:nvPr>
         </p:nvSpPr>
         <p:spPr>
@@ -2975,73 +2739,33 @@
           </a:p>
         </p:txBody>
       </p:sp>
-      <p:sp>
-        <p:nvSpPr>
-          <p:cNvPr id="4" name="Shape 2"/>
-          <p:cNvSpPr/>
+      <p:pic>
+        <p:nvPicPr>
+          <p:cNvPr id="4" name="Image 0" descr="/home/user/Claude/presentation/assets/cts-logo-dark.png">    </p:cNvPr>
+          <p:cNvPicPr>
+            <a:picLocks noChangeAspect="1"/>
+          </p:cNvPicPr>
           <p:nvPr/>
-        </p:nvSpPr>
-        <p:spPr>
-          <a:xfrm>
-            <a:off x="8257032" y="384048"/>
-            <a:ext cx="384048" cy="384048"/>
-          </a:xfrm>
-          <a:prstGeom prst="rect">
-            <a:avLst/>
-          </a:prstGeom>
-          <a:solidFill>
-            <a:srgbClr val="FFFFFF"/>
-          </a:solidFill>
-          <a:ln w="12700">
-            <a:solidFill>
-              <a:srgbClr val="FFFFFF"/>
-            </a:solidFill>
-            <a:prstDash val="solid"/>
-          </a:ln>
-        </p:spPr>
-      </p:sp>
-      <p:sp>
-        <p:nvSpPr>
-          <p:cNvPr id="5" name="Text 3"/>
-          <p:cNvSpPr/>
-          <p:nvPr/>
-        </p:nvSpPr>
-        <p:spPr>
-          <a:xfrm>
-            <a:off x="8257032" y="384048"/>
-            <a:ext cx="384048" cy="384048"/>
-          </a:xfrm>
-          <a:prstGeom prst="rect">
-            <a:avLst/>
-          </a:prstGeom>
-          <a:noFill/>
-          <a:ln/>
-        </p:spPr>
-        <p:txBody>
-          <a:bodyPr wrap="square" lIns="0" tIns="0" rIns="0" bIns="0" rtlCol="0" anchor="ctr"/>
-          <a:lstStyle/>
-          <a:p>
-            <a:pPr algn="ctr" indent="0" marL="0">
-              <a:buNone/>
-            </a:pPr>
-            <a:r>
-              <a:rPr lang="en-US" sz="1092" b="1" spc="100" kern="0" dirty="0">
-                <a:solidFill>
-                  <a:srgbClr val="121820"/>
-                </a:solidFill>
-                <a:latin typeface="Calibri" pitchFamily="34" charset="0"/>
-                <a:ea typeface="Calibri" pitchFamily="34" charset="-122"/>
-                <a:cs typeface="Calibri" pitchFamily="34" charset="-120"/>
-              </a:rPr>
-              <a:t>CTS</a:t>
-            </a:r>
-            <a:endParaRPr lang="en-US" sz="1092" dirty="0"/>
-          </a:p>
-        </p:txBody>
-      </p:sp>
-      <p:sp>
-        <p:nvSpPr>
-          <p:cNvPr id="6" name="Shape 4"/>
+        </p:nvPicPr>
+        <p:blipFill>
+          <a:blip r:embed="rId1"/>
+          <a:stretch>
+            <a:fillRect/>
+          </a:stretch>
+        </p:blipFill>
+        <p:spPr>
+          <a:xfrm>
+            <a:off x="7850089" y="384048"/>
+            <a:ext cx="790991" cy="537667"/>
+          </a:xfrm>
+          <a:prstGeom prst="rect">
+            <a:avLst/>
+          </a:prstGeom>
+        </p:spPr>
+      </p:pic>
+      <p:sp>
+        <p:nvSpPr>
+          <p:cNvPr id="5" name="Shape 2"/>
           <p:cNvSpPr/>
           <p:nvPr/>
         </p:nvSpPr>
@@ -3066,10 +2790,10 @@
       </p:sp>
       <p:sp>
         <p:nvSpPr>
-          <p:cNvPr id="7" name="Text 5"/>
+          <p:cNvPr id="6" name="Text 3"/>
           <p:cNvSpPr/>
           <p:nvPr>
-            <p:ph idx="105" type="body" hasCustomPrompt="1"/>
+            <p:ph idx="104" type="body" hasCustomPrompt="1"/>
           </p:nvPr>
         </p:nvSpPr>
         <p:spPr>
@@ -3119,10 +2843,10 @@
       </p:sp>
       <p:sp>
         <p:nvSpPr>
-          <p:cNvPr id="8" name="Text 5"/>
+          <p:cNvPr id="7" name="Text 3"/>
           <p:cNvSpPr/>
           <p:nvPr>
-            <p:ph idx="106" type="title" hasCustomPrompt="1"/>
+            <p:ph idx="105" type="title" hasCustomPrompt="1"/>
           </p:nvPr>
         </p:nvSpPr>
         <p:spPr>
@@ -3172,10 +2896,10 @@
       </p:sp>
       <p:sp>
         <p:nvSpPr>
-          <p:cNvPr id="9" name="Text 5"/>
+          <p:cNvPr id="8" name="Text 3"/>
           <p:cNvSpPr/>
           <p:nvPr>
-            <p:ph idx="107" type="body" hasCustomPrompt="1"/>
+            <p:ph idx="106" type="body" hasCustomPrompt="1"/>
           </p:nvPr>
         </p:nvSpPr>
         <p:spPr>
@@ -3225,7 +2949,7 @@
       </p:sp>
       <p:sp>
         <p:nvSpPr>
-          <p:cNvPr id="10" name="Text 5"/>
+          <p:cNvPr id="9" name="Text 3"/>
           <p:cNvSpPr/>
           <p:nvPr/>
         </p:nvSpPr>
@@ -3448,73 +3172,33 @@
           </a:p>
         </p:txBody>
       </p:sp>
-      <p:sp>
-        <p:nvSpPr>
-          <p:cNvPr id="4" name="Shape 0"/>
-          <p:cNvSpPr/>
+      <p:pic>
+        <p:nvPicPr>
+          <p:cNvPr id="4" name="Image 0" descr="/home/user/Claude/presentation/assets/cts-logo.png">    </p:cNvPr>
+          <p:cNvPicPr>
+            <a:picLocks noChangeAspect="1"/>
+          </p:cNvPicPr>
           <p:nvPr/>
-        </p:nvSpPr>
-        <p:spPr>
-          <a:xfrm>
-            <a:off x="8257032" y="384048"/>
-            <a:ext cx="384048" cy="384048"/>
-          </a:xfrm>
-          <a:prstGeom prst="rect">
-            <a:avLst/>
-          </a:prstGeom>
-          <a:solidFill>
-            <a:srgbClr val="121820"/>
-          </a:solidFill>
-          <a:ln w="12700">
-            <a:solidFill>
-              <a:srgbClr val="121820"/>
-            </a:solidFill>
-            <a:prstDash val="solid"/>
-          </a:ln>
-        </p:spPr>
-      </p:sp>
-      <p:sp>
-        <p:nvSpPr>
-          <p:cNvPr id="5" name="Text 1"/>
-          <p:cNvSpPr/>
-          <p:nvPr/>
-        </p:nvSpPr>
-        <p:spPr>
-          <a:xfrm>
-            <a:off x="8257032" y="384048"/>
-            <a:ext cx="384048" cy="384048"/>
-          </a:xfrm>
-          <a:prstGeom prst="rect">
-            <a:avLst/>
-          </a:prstGeom>
-          <a:noFill/>
-          <a:ln/>
-        </p:spPr>
-        <p:txBody>
-          <a:bodyPr wrap="square" lIns="0" tIns="0" rIns="0" bIns="0" rtlCol="0" anchor="ctr"/>
-          <a:lstStyle/>
-          <a:p>
-            <a:pPr algn="ctr" indent="0" marL="0">
-              <a:buNone/>
-            </a:pPr>
-            <a:r>
-              <a:rPr lang="en-US" sz="1092" b="1" spc="100" kern="0" dirty="0">
-                <a:solidFill>
-                  <a:srgbClr val="FFFFFF"/>
-                </a:solidFill>
-                <a:latin typeface="Calibri" pitchFamily="34" charset="0"/>
-                <a:ea typeface="Calibri" pitchFamily="34" charset="-122"/>
-                <a:cs typeface="Calibri" pitchFamily="34" charset="-120"/>
-              </a:rPr>
-              <a:t>CTS</a:t>
-            </a:r>
-            <a:endParaRPr lang="en-US" sz="1092" dirty="0"/>
-          </a:p>
-        </p:txBody>
-      </p:sp>
-      <p:sp>
-        <p:nvSpPr>
-          <p:cNvPr id="6" name="Text 2"/>
+        </p:nvPicPr>
+        <p:blipFill>
+          <a:blip r:embed="rId1"/>
+          <a:stretch>
+            <a:fillRect/>
+          </a:stretch>
+        </p:blipFill>
+        <p:spPr>
+          <a:xfrm>
+            <a:off x="7850089" y="384048"/>
+            <a:ext cx="790991" cy="537667"/>
+          </a:xfrm>
+          <a:prstGeom prst="rect">
+            <a:avLst/>
+          </a:prstGeom>
+        </p:spPr>
+      </p:pic>
+      <p:sp>
+        <p:nvSpPr>
+          <p:cNvPr id="5" name="Text 0"/>
           <p:cNvSpPr/>
           <p:nvPr/>
         </p:nvSpPr>
@@ -3737,41 +3421,40 @@
           </a:p>
         </p:txBody>
       </p:sp>
-      <p:sp>
-        <p:nvSpPr>
-          <p:cNvPr id="4" name="Shape 0"/>
+      <p:pic>
+        <p:nvPicPr>
+          <p:cNvPr id="4" name="Image 0" descr="/home/user/Claude/presentation/assets/cts-logo.png">    </p:cNvPr>
+          <p:cNvPicPr>
+            <a:picLocks noChangeAspect="1"/>
+          </p:cNvPicPr>
+          <p:nvPr/>
+        </p:nvPicPr>
+        <p:blipFill>
+          <a:blip r:embed="rId1"/>
+          <a:stretch>
+            <a:fillRect/>
+          </a:stretch>
+        </p:blipFill>
+        <p:spPr>
+          <a:xfrm>
+            <a:off x="7850089" y="384048"/>
+            <a:ext cx="790991" cy="537667"/>
+          </a:xfrm>
+          <a:prstGeom prst="rect">
+            <a:avLst/>
+          </a:prstGeom>
+        </p:spPr>
+      </p:pic>
+      <p:sp>
+        <p:nvSpPr>
+          <p:cNvPr id="5" name="Text 0"/>
           <p:cNvSpPr/>
           <p:nvPr/>
         </p:nvSpPr>
         <p:spPr>
           <a:xfrm>
-            <a:off x="8257032" y="384048"/>
-            <a:ext cx="384048" cy="384048"/>
-          </a:xfrm>
-          <a:prstGeom prst="rect">
-            <a:avLst/>
-          </a:prstGeom>
-          <a:solidFill>
-            <a:srgbClr val="121820"/>
-          </a:solidFill>
-          <a:ln w="12700">
-            <a:solidFill>
-              <a:srgbClr val="121820"/>
-            </a:solidFill>
-            <a:prstDash val="solid"/>
-          </a:ln>
-        </p:spPr>
-      </p:sp>
-      <p:sp>
-        <p:nvSpPr>
-          <p:cNvPr id="5" name="Text 1"/>
-          <p:cNvSpPr/>
-          <p:nvPr/>
-        </p:nvSpPr>
-        <p:spPr>
-          <a:xfrm>
-            <a:off x="8257032" y="384048"/>
-            <a:ext cx="384048" cy="384048"/>
+            <a:off x="502920" y="4759452"/>
+            <a:ext cx="4114800" cy="228600"/>
           </a:xfrm>
           <a:prstGeom prst="rect">
             <a:avLst/>
@@ -3783,45 +3466,6 @@
           <a:bodyPr wrap="square" lIns="0" tIns="0" rIns="0" bIns="0" rtlCol="0" anchor="ctr"/>
           <a:lstStyle/>
           <a:p>
-            <a:pPr algn="ctr" indent="0" marL="0">
-              <a:buNone/>
-            </a:pPr>
-            <a:r>
-              <a:rPr lang="en-US" sz="1092" b="1" spc="100" kern="0" dirty="0">
-                <a:solidFill>
-                  <a:srgbClr val="FFFFFF"/>
-                </a:solidFill>
-                <a:latin typeface="Calibri" pitchFamily="34" charset="0"/>
-                <a:ea typeface="Calibri" pitchFamily="34" charset="-122"/>
-                <a:cs typeface="Calibri" pitchFamily="34" charset="-120"/>
-              </a:rPr>
-              <a:t>CTS</a:t>
-            </a:r>
-            <a:endParaRPr lang="en-US" sz="1092" dirty="0"/>
-          </a:p>
-        </p:txBody>
-      </p:sp>
-      <p:sp>
-        <p:nvSpPr>
-          <p:cNvPr id="6" name="Text 2"/>
-          <p:cNvSpPr/>
-          <p:nvPr/>
-        </p:nvSpPr>
-        <p:spPr>
-          <a:xfrm>
-            <a:off x="502920" y="4759452"/>
-            <a:ext cx="4114800" cy="228600"/>
-          </a:xfrm>
-          <a:prstGeom prst="rect">
-            <a:avLst/>
-          </a:prstGeom>
-          <a:noFill/>
-          <a:ln/>
-        </p:spPr>
-        <p:txBody>
-          <a:bodyPr wrap="square" lIns="0" tIns="0" rIns="0" bIns="0" rtlCol="0" anchor="ctr"/>
-          <a:lstStyle/>
-          <a:p>
             <a:pPr indent="0" marL="0">
               <a:buNone/>
             </a:pPr>
@@ -3842,10 +3486,10 @@
       </p:sp>
       <p:sp>
         <p:nvSpPr>
-          <p:cNvPr id="7" name="Text 3"/>
+          <p:cNvPr id="6" name="Text 1"/>
           <p:cNvSpPr/>
           <p:nvPr>
-            <p:ph idx="105" type="body" hasCustomPrompt="1"/>
+            <p:ph idx="104" type="body" hasCustomPrompt="1"/>
           </p:nvPr>
         </p:nvSpPr>
         <p:spPr>
@@ -4306,10 +3950,10 @@
       </p:grpSpPr>
       <p:sp>
         <p:nvSpPr>
-          <p:cNvPr id="2" name="Text 7"/>
+          <p:cNvPr id="2" name="Text 3"/>
           <p:cNvSpPr/>
           <p:nvPr>
-            <p:ph idx="107" type="body" hasCustomPrompt="1"/>
+            <p:ph idx="104" type="body" hasCustomPrompt="1"/>
           </p:nvPr>
         </p:nvSpPr>
         <p:spPr>
@@ -4347,10 +3991,10 @@
       </p:sp>
       <p:sp>
         <p:nvSpPr>
-          <p:cNvPr id="3" name="Text 7"/>
+          <p:cNvPr id="3" name="Text 3"/>
           <p:cNvSpPr/>
           <p:nvPr>
-            <p:ph idx="108" type="title" hasCustomPrompt="1"/>
+            <p:ph idx="105" type="title" hasCustomPrompt="1"/>
           </p:nvPr>
         </p:nvSpPr>
         <p:spPr>
@@ -4388,10 +4032,10 @@
       </p:sp>
       <p:sp>
         <p:nvSpPr>
-          <p:cNvPr id="4" name="Text 7"/>
+          <p:cNvPr id="4" name="Text 3"/>
           <p:cNvSpPr/>
           <p:nvPr>
-            <p:ph idx="109" type="body" hasCustomPrompt="1"/>
+            <p:ph idx="106" type="body" hasCustomPrompt="1"/>
           </p:nvPr>
         </p:nvSpPr>
         <p:spPr>
@@ -4429,10 +4073,10 @@
       </p:sp>
       <p:sp>
         <p:nvSpPr>
-          <p:cNvPr id="5" name="Text 7"/>
+          <p:cNvPr id="5" name="Text 3"/>
           <p:cNvSpPr/>
           <p:nvPr>
-            <p:ph idx="110" type="body" hasCustomPrompt="1"/>
+            <p:ph idx="107" type="body" hasCustomPrompt="1"/>
           </p:nvPr>
         </p:nvSpPr>
         <p:spPr>
@@ -4470,10 +4114,10 @@
       </p:sp>
       <p:sp>
         <p:nvSpPr>
-          <p:cNvPr id="6" name="Text 7"/>
+          <p:cNvPr id="6" name="Text 3"/>
           <p:cNvSpPr/>
           <p:nvPr>
-            <p:ph idx="111" type="body" hasCustomPrompt="1"/>
+            <p:ph idx="108" type="body" hasCustomPrompt="1"/>
           </p:nvPr>
         </p:nvSpPr>
         <p:spPr>
@@ -4536,10 +4180,10 @@
       </p:grpSpPr>
       <p:sp>
         <p:nvSpPr>
-          <p:cNvPr id="2" name="Text 9"/>
+          <p:cNvPr id="2" name="Text 5"/>
           <p:cNvSpPr/>
           <p:nvPr>
-            <p:ph idx="109" type="body" hasCustomPrompt="1"/>
+            <p:ph idx="106" type="body" hasCustomPrompt="1"/>
           </p:nvPr>
         </p:nvSpPr>
         <p:spPr>
@@ -4577,10 +4221,10 @@
       </p:sp>
       <p:sp>
         <p:nvSpPr>
-          <p:cNvPr id="3" name="Text 9"/>
+          <p:cNvPr id="3" name="Text 5"/>
           <p:cNvSpPr/>
           <p:nvPr>
-            <p:ph idx="110" type="title" hasCustomPrompt="1"/>
+            <p:ph idx="107" type="title" hasCustomPrompt="1"/>
           </p:nvPr>
         </p:nvSpPr>
         <p:spPr>
@@ -4618,10 +4262,10 @@
       </p:sp>
       <p:sp>
         <p:nvSpPr>
-          <p:cNvPr id="4" name="Text 9"/>
+          <p:cNvPr id="4" name="Text 5"/>
           <p:cNvSpPr/>
           <p:nvPr>
-            <p:ph idx="111" type="body" hasCustomPrompt="1"/>
+            <p:ph idx="108" type="body" hasCustomPrompt="1"/>
           </p:nvPr>
         </p:nvSpPr>
         <p:spPr>
@@ -4659,10 +4303,10 @@
       </p:sp>
       <p:sp>
         <p:nvSpPr>
-          <p:cNvPr id="5" name="Text 9"/>
+          <p:cNvPr id="5" name="Text 5"/>
           <p:cNvSpPr/>
           <p:nvPr>
-            <p:ph idx="112" type="body" hasCustomPrompt="1"/>
+            <p:ph idx="109" type="body" hasCustomPrompt="1"/>
           </p:nvPr>
         </p:nvSpPr>
         <p:spPr>
@@ -4700,10 +4344,10 @@
       </p:sp>
       <p:sp>
         <p:nvSpPr>
-          <p:cNvPr id="6" name="Text 9"/>
+          <p:cNvPr id="6" name="Text 5"/>
           <p:cNvSpPr/>
           <p:nvPr>
-            <p:ph idx="113" type="body" hasCustomPrompt="1"/>
+            <p:ph idx="110" type="body" hasCustomPrompt="1"/>
           </p:nvPr>
         </p:nvSpPr>
         <p:spPr>
@@ -4766,10 +4410,10 @@
       </p:grpSpPr>
       <p:sp>
         <p:nvSpPr>
-          <p:cNvPr id="2" name="Text 5"/>
+          <p:cNvPr id="2" name="Text 3"/>
           <p:cNvSpPr/>
           <p:nvPr>
-            <p:ph idx="105" type="body" hasCustomPrompt="1"/>
+            <p:ph idx="104" type="body" hasCustomPrompt="1"/>
           </p:nvPr>
         </p:nvSpPr>
         <p:spPr>
@@ -4807,10 +4451,10 @@
       </p:sp>
       <p:sp>
         <p:nvSpPr>
-          <p:cNvPr id="3" name="Text 5"/>
+          <p:cNvPr id="3" name="Text 3"/>
           <p:cNvSpPr/>
           <p:nvPr>
-            <p:ph idx="106" type="title" hasCustomPrompt="1"/>
+            <p:ph idx="105" type="title" hasCustomPrompt="1"/>
           </p:nvPr>
         </p:nvSpPr>
         <p:spPr>
@@ -4848,10 +4492,10 @@
       </p:sp>
       <p:sp>
         <p:nvSpPr>
-          <p:cNvPr id="4" name="Text 5"/>
+          <p:cNvPr id="4" name="Text 3"/>
           <p:cNvSpPr/>
           <p:nvPr>
-            <p:ph idx="107" type="body" hasCustomPrompt="1"/>
+            <p:ph idx="106" type="body" hasCustomPrompt="1"/>
           </p:nvPr>
         </p:nvSpPr>
         <p:spPr>
@@ -4962,10 +4606,10 @@
       </p:grpSpPr>
       <p:sp>
         <p:nvSpPr>
-          <p:cNvPr id="2" name="Text 5"/>
+          <p:cNvPr id="2" name="Text 3"/>
           <p:cNvSpPr/>
           <p:nvPr>
-            <p:ph idx="105" type="body" hasCustomPrompt="1"/>
+            <p:ph idx="104" type="body" hasCustomPrompt="1"/>
           </p:nvPr>
         </p:nvSpPr>
         <p:spPr>
@@ -5003,10 +4647,10 @@
       </p:sp>
       <p:sp>
         <p:nvSpPr>
-          <p:cNvPr id="3" name="Text 5"/>
+          <p:cNvPr id="3" name="Text 3"/>
           <p:cNvSpPr/>
           <p:nvPr>
-            <p:ph idx="106" type="title" hasCustomPrompt="1"/>
+            <p:ph idx="105" type="title" hasCustomPrompt="1"/>
           </p:nvPr>
         </p:nvSpPr>
         <p:spPr>
@@ -5044,10 +4688,10 @@
       </p:sp>
       <p:sp>
         <p:nvSpPr>
-          <p:cNvPr id="4" name="Text 5"/>
+          <p:cNvPr id="4" name="Text 3"/>
           <p:cNvSpPr/>
           <p:nvPr>
-            <p:ph idx="107" type="body" hasCustomPrompt="1"/>
+            <p:ph idx="106" type="body" hasCustomPrompt="1"/>
           </p:nvPr>
         </p:nvSpPr>
         <p:spPr>
@@ -5566,10 +5210,10 @@
       </p:sp>
       <p:sp>
         <p:nvSpPr>
-          <p:cNvPr id="4" name="Text 3"/>
+          <p:cNvPr id="4" name="Text 1"/>
           <p:cNvSpPr/>
           <p:nvPr>
-            <p:ph idx="105" type="body" hasCustomPrompt="1"/>
+            <p:ph idx="104" type="body" hasCustomPrompt="1"/>
           </p:nvPr>
         </p:nvSpPr>
         <p:spPr>
@@ -6085,10 +5729,10 @@
       </p:sp>
       <p:sp>
         <p:nvSpPr>
-          <p:cNvPr id="10" name="Text 3"/>
+          <p:cNvPr id="10" name="Text 1"/>
           <p:cNvSpPr/>
           <p:nvPr>
-            <p:ph idx="105" type="body" hasCustomPrompt="1"/>
+            <p:ph idx="104" type="body" hasCustomPrompt="1"/>
           </p:nvPr>
         </p:nvSpPr>
         <p:spPr>

</xml_diff>

<commit_message>
Use CTS charcoal 1A1A1A as the base colour instead of 121820
The website stylesheet, the charcoal logo export and the brand strategy
pages all use 1A1A1A; the palette PDF's hex was the outlier and its own
RGB column agrees with 1A1A1A. Updates the template, the black logo SVG
variants and the README.

Co-Authored-By: Claude Fable 5.1 <noreply@anthropic.com>
Claude-Session: https://claude.ai/code/session_01XrzJEmFyMntLmpxLDC4vTY
</commit_message>
<xml_diff>
--- a/presentation/CTS Presentation Template.pptx
+++ b/presentation/CTS Presentation Template.pptx
@@ -3016,7 +3016,7 @@
               <a:buNone/>
               <a:defRPr lang="en-US" sz="4800" b="1" dirty="0">
                 <a:solidFill>
-                  <a:srgbClr val="121820"/>
+                  <a:srgbClr val="1A1A1A"/>
                 </a:solidFill>
                 <a:latin typeface="Calibri" pitchFamily="34" charset="0"/>
                 <a:ea typeface="Calibri" pitchFamily="34" charset="-122"/>
@@ -3031,7 +3031,7 @@
             <a:r>
               <a:rPr lang="en-US" sz="4800" b="1" dirty="0">
                 <a:solidFill>
-                  <a:srgbClr val="121820"/>
+                  <a:srgbClr val="1A1A1A"/>
                 </a:solidFill>
                 <a:latin typeface="Calibri" pitchFamily="34" charset="0"/>
                 <a:ea typeface="Calibri" pitchFamily="34" charset="-122"/>
@@ -3411,7 +3411,7 @@
               <a:buNone/>
               <a:defRPr lang="en-US" sz="4800" b="1" dirty="0">
                 <a:solidFill>
-                  <a:srgbClr val="121820"/>
+                  <a:srgbClr val="1A1A1A"/>
                 </a:solidFill>
                 <a:latin typeface="Calibri" pitchFamily="34" charset="0"/>
                 <a:ea typeface="Calibri" pitchFamily="34" charset="-122"/>
@@ -3426,7 +3426,7 @@
             <a:r>
               <a:rPr lang="en-US" sz="4800" b="1" dirty="0">
                 <a:solidFill>
-                  <a:srgbClr val="121820"/>
+                  <a:srgbClr val="1A1A1A"/>
                 </a:solidFill>
                 <a:latin typeface="Calibri" pitchFamily="34" charset="0"/>
                 <a:ea typeface="Calibri" pitchFamily="34" charset="-122"/>
@@ -3806,7 +3806,7 @@
               <a:buNone/>
               <a:defRPr lang="en-US" sz="4800" b="1" dirty="0">
                 <a:solidFill>
-                  <a:srgbClr val="121820"/>
+                  <a:srgbClr val="1A1A1A"/>
                 </a:solidFill>
                 <a:latin typeface="Calibri" pitchFamily="34" charset="0"/>
                 <a:ea typeface="Calibri" pitchFamily="34" charset="-122"/>
@@ -3821,7 +3821,7 @@
             <a:r>
               <a:rPr lang="en-US" sz="4800" b="1" dirty="0">
                 <a:solidFill>
-                  <a:srgbClr val="121820"/>
+                  <a:srgbClr val="1A1A1A"/>
                 </a:solidFill>
                 <a:latin typeface="Calibri" pitchFamily="34" charset="0"/>
                 <a:ea typeface="Calibri" pitchFamily="34" charset="-122"/>
@@ -4137,7 +4137,7 @@
               <a:buNone/>
               <a:defRPr lang="en-US" sz="2800" b="1" dirty="0">
                 <a:solidFill>
-                  <a:srgbClr val="121820"/>
+                  <a:srgbClr val="1A1A1A"/>
                 </a:solidFill>
                 <a:latin typeface="Calibri" pitchFamily="34" charset="0"/>
                 <a:ea typeface="Calibri" pitchFamily="34" charset="-122"/>
@@ -4152,7 +4152,7 @@
             <a:r>
               <a:rPr lang="en-US" sz="2800" b="1" dirty="0">
                 <a:solidFill>
-                  <a:srgbClr val="121820"/>
+                  <a:srgbClr val="1A1A1A"/>
                 </a:solidFill>
                 <a:latin typeface="Calibri" pitchFamily="34" charset="0"/>
                 <a:ea typeface="Calibri" pitchFamily="34" charset="-122"/>
@@ -4386,7 +4386,7 @@
               <a:buNone/>
               <a:defRPr lang="en-US" sz="2800" b="1" dirty="0">
                 <a:solidFill>
-                  <a:srgbClr val="121820"/>
+                  <a:srgbClr val="1A1A1A"/>
                 </a:solidFill>
                 <a:latin typeface="Calibri" pitchFamily="34" charset="0"/>
                 <a:ea typeface="Calibri" pitchFamily="34" charset="-122"/>
@@ -4401,7 +4401,7 @@
             <a:r>
               <a:rPr lang="en-US" sz="2800" b="1" dirty="0">
                 <a:solidFill>
-                  <a:srgbClr val="121820"/>
+                  <a:srgbClr val="1A1A1A"/>
                 </a:solidFill>
                 <a:latin typeface="Calibri" pitchFamily="34" charset="0"/>
                 <a:ea typeface="Calibri" pitchFamily="34" charset="-122"/>
@@ -4506,7 +4506,7 @@
               <a:buChar char="•"/>
               <a:defRPr lang="en-US" sz="1600" dirty="0">
                 <a:solidFill>
-                  <a:srgbClr val="121820"/>
+                  <a:srgbClr val="1A1A1A"/>
                 </a:solidFill>
                 <a:latin typeface="Calibri" pitchFamily="34" charset="0"/>
                 <a:ea typeface="Calibri" pitchFamily="34" charset="-122"/>
@@ -4525,7 +4525,7 @@
             <a:r>
               <a:rPr lang="en-US" sz="1600" dirty="0">
                 <a:solidFill>
-                  <a:srgbClr val="121820"/>
+                  <a:srgbClr val="1A1A1A"/>
                 </a:solidFill>
                 <a:latin typeface="Calibri" pitchFamily="34" charset="0"/>
                 <a:ea typeface="Calibri" pitchFamily="34" charset="-122"/>
@@ -4696,7 +4696,7 @@
               <a:buNone/>
               <a:defRPr lang="en-US" sz="2800" b="1" dirty="0">
                 <a:solidFill>
-                  <a:srgbClr val="121820"/>
+                  <a:srgbClr val="1A1A1A"/>
                 </a:solidFill>
                 <a:latin typeface="Calibri" pitchFamily="34" charset="0"/>
                 <a:ea typeface="Calibri" pitchFamily="34" charset="-122"/>
@@ -4711,7 +4711,7 @@
             <a:r>
               <a:rPr lang="en-US" sz="2800" b="1" dirty="0">
                 <a:solidFill>
-                  <a:srgbClr val="121820"/>
+                  <a:srgbClr val="1A1A1A"/>
                 </a:solidFill>
                 <a:latin typeface="Calibri" pitchFamily="34" charset="0"/>
                 <a:ea typeface="Calibri" pitchFamily="34" charset="-122"/>
@@ -4945,7 +4945,7 @@
               <a:buNone/>
               <a:defRPr lang="en-US" sz="2800" b="1" dirty="0">
                 <a:solidFill>
-                  <a:srgbClr val="121820"/>
+                  <a:srgbClr val="1A1A1A"/>
                 </a:solidFill>
                 <a:latin typeface="Calibri" pitchFamily="34" charset="0"/>
                 <a:ea typeface="Calibri" pitchFamily="34" charset="-122"/>
@@ -4960,7 +4960,7 @@
             <a:r>
               <a:rPr lang="en-US" sz="2800" b="1" dirty="0">
                 <a:solidFill>
-                  <a:srgbClr val="121820"/>
+                  <a:srgbClr val="1A1A1A"/>
                 </a:solidFill>
                 <a:latin typeface="Calibri" pitchFamily="34" charset="0"/>
                 <a:ea typeface="Calibri" pitchFamily="34" charset="-122"/>
@@ -5065,7 +5065,7 @@
               <a:buChar char="•"/>
               <a:defRPr lang="en-US" sz="1600" dirty="0">
                 <a:solidFill>
-                  <a:srgbClr val="121820"/>
+                  <a:srgbClr val="1A1A1A"/>
                 </a:solidFill>
                 <a:latin typeface="Calibri" pitchFamily="34" charset="0"/>
                 <a:ea typeface="Calibri" pitchFamily="34" charset="-122"/>
@@ -5084,7 +5084,7 @@
             <a:r>
               <a:rPr lang="en-US" sz="1600" dirty="0">
                 <a:solidFill>
-                  <a:srgbClr val="121820"/>
+                  <a:srgbClr val="1A1A1A"/>
                 </a:solidFill>
                 <a:latin typeface="Calibri" pitchFamily="34" charset="0"/>
                 <a:ea typeface="Calibri" pitchFamily="34" charset="-122"/>
@@ -5255,7 +5255,7 @@
               <a:buNone/>
               <a:defRPr lang="en-US" sz="2800" b="1" dirty="0">
                 <a:solidFill>
-                  <a:srgbClr val="121820"/>
+                  <a:srgbClr val="1A1A1A"/>
                 </a:solidFill>
                 <a:latin typeface="Calibri" pitchFamily="34" charset="0"/>
                 <a:ea typeface="Calibri" pitchFamily="34" charset="-122"/>
@@ -5270,7 +5270,7 @@
             <a:r>
               <a:rPr lang="en-US" sz="2800" b="1" dirty="0">
                 <a:solidFill>
-                  <a:srgbClr val="121820"/>
+                  <a:srgbClr val="1A1A1A"/>
                 </a:solidFill>
                 <a:latin typeface="Calibri" pitchFamily="34" charset="0"/>
                 <a:ea typeface="Calibri" pitchFamily="34" charset="-122"/>
@@ -5504,7 +5504,7 @@
               <a:buNone/>
               <a:defRPr lang="en-US" sz="2800" b="1" dirty="0">
                 <a:solidFill>
-                  <a:srgbClr val="121820"/>
+                  <a:srgbClr val="1A1A1A"/>
                 </a:solidFill>
                 <a:latin typeface="Calibri" pitchFamily="34" charset="0"/>
                 <a:ea typeface="Calibri" pitchFamily="34" charset="-122"/>
@@ -5519,7 +5519,7 @@
             <a:r>
               <a:rPr lang="en-US" sz="2800" b="1" dirty="0">
                 <a:solidFill>
-                  <a:srgbClr val="121820"/>
+                  <a:srgbClr val="1A1A1A"/>
                 </a:solidFill>
                 <a:latin typeface="Calibri" pitchFamily="34" charset="0"/>
                 <a:ea typeface="Calibri" pitchFamily="34" charset="-122"/>
@@ -5624,7 +5624,7 @@
               <a:buChar char="•"/>
               <a:defRPr lang="en-US" sz="1600" dirty="0">
                 <a:solidFill>
-                  <a:srgbClr val="121820"/>
+                  <a:srgbClr val="1A1A1A"/>
                 </a:solidFill>
                 <a:latin typeface="Calibri" pitchFamily="34" charset="0"/>
                 <a:ea typeface="Calibri" pitchFamily="34" charset="-122"/>
@@ -5643,7 +5643,7 @@
             <a:r>
               <a:rPr lang="en-US" sz="1600" dirty="0">
                 <a:solidFill>
-                  <a:srgbClr val="121820"/>
+                  <a:srgbClr val="1A1A1A"/>
                 </a:solidFill>
                 <a:latin typeface="Calibri" pitchFamily="34" charset="0"/>
                 <a:ea typeface="Calibri" pitchFamily="34" charset="-122"/>
@@ -5814,7 +5814,7 @@
               <a:buNone/>
               <a:defRPr lang="en-US" sz="2800" b="1" dirty="0">
                 <a:solidFill>
-                  <a:srgbClr val="121820"/>
+                  <a:srgbClr val="1A1A1A"/>
                 </a:solidFill>
                 <a:latin typeface="Calibri" pitchFamily="34" charset="0"/>
                 <a:ea typeface="Calibri" pitchFamily="34" charset="-122"/>
@@ -5829,7 +5829,7 @@
             <a:r>
               <a:rPr lang="en-US" sz="2800" b="1" dirty="0">
                 <a:solidFill>
-                  <a:srgbClr val="121820"/>
+                  <a:srgbClr val="1A1A1A"/>
                 </a:solidFill>
                 <a:latin typeface="Calibri" pitchFamily="34" charset="0"/>
                 <a:ea typeface="Calibri" pitchFamily="34" charset="-122"/>
@@ -5966,7 +5966,7 @@
     <p:bg>
       <p:bgPr>
         <a:solidFill>
-          <a:srgbClr val="121820"/>
+          <a:srgbClr val="1A1A1A"/>
         </a:solidFill>
       </p:bgPr>
     </p:bg>
@@ -6471,7 +6471,7 @@
               <a:buNone/>
               <a:defRPr lang="en-US" sz="2800" b="1" dirty="0">
                 <a:solidFill>
-                  <a:srgbClr val="121820"/>
+                  <a:srgbClr val="1A1A1A"/>
                 </a:solidFill>
                 <a:latin typeface="Calibri" pitchFamily="34" charset="0"/>
                 <a:ea typeface="Calibri" pitchFamily="34" charset="-122"/>
@@ -6486,7 +6486,7 @@
             <a:r>
               <a:rPr lang="en-US" sz="2800" b="1" dirty="0">
                 <a:solidFill>
-                  <a:srgbClr val="121820"/>
+                  <a:srgbClr val="1A1A1A"/>
                 </a:solidFill>
                 <a:latin typeface="Calibri" pitchFamily="34" charset="0"/>
                 <a:ea typeface="Calibri" pitchFamily="34" charset="-122"/>
@@ -6591,7 +6591,7 @@
               <a:buChar char="•"/>
               <a:defRPr lang="en-US" sz="1600" dirty="0">
                 <a:solidFill>
-                  <a:srgbClr val="121820"/>
+                  <a:srgbClr val="1A1A1A"/>
                 </a:solidFill>
                 <a:latin typeface="Calibri" pitchFamily="34" charset="0"/>
                 <a:ea typeface="Calibri" pitchFamily="34" charset="-122"/>
@@ -6610,7 +6610,7 @@
             <a:r>
               <a:rPr lang="en-US" sz="1600" dirty="0">
                 <a:solidFill>
-                  <a:srgbClr val="121820"/>
+                  <a:srgbClr val="1A1A1A"/>
                 </a:solidFill>
                 <a:latin typeface="Calibri" pitchFamily="34" charset="0"/>
                 <a:ea typeface="Calibri" pitchFamily="34" charset="-122"/>
@@ -6717,11 +6717,11 @@
             <a:avLst/>
           </a:prstGeom>
           <a:solidFill>
-            <a:srgbClr val="121820"/>
+            <a:srgbClr val="1A1A1A"/>
           </a:solidFill>
           <a:ln w="12700">
             <a:solidFill>
-              <a:srgbClr val="121820"/>
+              <a:srgbClr val="1A1A1A"/>
             </a:solidFill>
             <a:prstDash val="solid"/>
           </a:ln>
@@ -6942,7 +6942,7 @@
               <a:buNone/>
               <a:defRPr lang="en-US" sz="3600" b="1" dirty="0">
                 <a:solidFill>
-                  <a:srgbClr val="121820"/>
+                  <a:srgbClr val="1A1A1A"/>
                 </a:solidFill>
                 <a:latin typeface="Calibri" pitchFamily="34" charset="0"/>
                 <a:ea typeface="Calibri" pitchFamily="34" charset="-122"/>
@@ -6957,7 +6957,7 @@
             <a:r>
               <a:rPr lang="en-US" sz="3600" b="1" dirty="0">
                 <a:solidFill>
-                  <a:srgbClr val="121820"/>
+                  <a:srgbClr val="1A1A1A"/>
                 </a:solidFill>
                 <a:latin typeface="Calibri" pitchFamily="34" charset="0"/>
                 <a:ea typeface="Calibri" pitchFamily="34" charset="-122"/>
@@ -7142,7 +7142,7 @@
     <p:bg>
       <p:bgPr>
         <a:solidFill>
-          <a:srgbClr val="121820"/>
+          <a:srgbClr val="1A1A1A"/>
         </a:solidFill>
       </p:bgPr>
     </p:bg>
@@ -7492,7 +7492,7 @@
     <p:bg>
       <p:bgPr>
         <a:solidFill>
-          <a:srgbClr val="121820"/>
+          <a:srgbClr val="1A1A1A"/>
         </a:solidFill>
       </p:bgPr>
     </p:bg>
@@ -7871,7 +7871,7 @@
     <p:bg>
       <p:bgPr>
         <a:solidFill>
-          <a:srgbClr val="121820"/>
+          <a:srgbClr val="1A1A1A"/>
         </a:solidFill>
       </p:bgPr>
     </p:bg>
@@ -8250,7 +8250,7 @@
     <p:bg>
       <p:bgPr>
         <a:solidFill>
-          <a:srgbClr val="121820"/>
+          <a:srgbClr val="1A1A1A"/>
         </a:solidFill>
       </p:bgPr>
     </p:bg>
@@ -8790,7 +8790,7 @@
               <a:buNone/>
               <a:defRPr lang="en-US" sz="4800" b="1" dirty="0">
                 <a:solidFill>
-                  <a:srgbClr val="121820"/>
+                  <a:srgbClr val="1A1A1A"/>
                 </a:solidFill>
                 <a:latin typeface="Calibri" pitchFamily="34" charset="0"/>
                 <a:ea typeface="Calibri" pitchFamily="34" charset="-122"/>
@@ -8805,7 +8805,7 @@
             <a:r>
               <a:rPr lang="en-US" sz="4800" b="1" dirty="0">
                 <a:solidFill>
-                  <a:srgbClr val="121820"/>
+                  <a:srgbClr val="1A1A1A"/>
                 </a:solidFill>
                 <a:latin typeface="Calibri" pitchFamily="34" charset="0"/>
                 <a:ea typeface="Calibri" pitchFamily="34" charset="-122"/>
@@ -9149,11 +9149,11 @@
             <a:avLst/>
           </a:prstGeom>
           <a:solidFill>
-            <a:srgbClr val="121820"/>
+            <a:srgbClr val="1A1A1A"/>
           </a:solidFill>
           <a:ln w="12700">
             <a:solidFill>
-              <a:srgbClr val="121820"/>
+              <a:srgbClr val="1A1A1A"/>
             </a:solidFill>
             <a:prstDash val="solid"/>
           </a:ln>
@@ -9238,7 +9238,7 @@
               <a:buNone/>
               <a:defRPr lang="en-US" sz="3600" b="1" dirty="0">
                 <a:solidFill>
-                  <a:srgbClr val="121820"/>
+                  <a:srgbClr val="1A1A1A"/>
                 </a:solidFill>
                 <a:latin typeface="Calibri" pitchFamily="34" charset="0"/>
                 <a:ea typeface="Calibri" pitchFamily="34" charset="-122"/>
@@ -9253,7 +9253,7 @@
             <a:r>
               <a:rPr lang="en-US" sz="3600" b="1" dirty="0">
                 <a:solidFill>
-                  <a:srgbClr val="121820"/>
+                  <a:srgbClr val="1A1A1A"/>
                 </a:solidFill>
                 <a:latin typeface="Calibri" pitchFamily="34" charset="0"/>
                 <a:ea typeface="Calibri" pitchFamily="34" charset="-122"/>
@@ -10033,7 +10033,7 @@
             <a:r>
               <a:rPr lang="en-US" sz="4800" b="1" dirty="0">
                 <a:solidFill>
-                  <a:srgbClr val="121820"/>
+                  <a:srgbClr val="1A1A1A"/>
                 </a:solidFill>
                 <a:latin typeface="Calibri" pitchFamily="34" charset="0"/>
                 <a:ea typeface="Calibri" pitchFamily="34" charset="-122"/>
@@ -10229,7 +10229,7 @@
             <a:r>
               <a:rPr lang="en-US" sz="4800" b="1" dirty="0">
                 <a:solidFill>
-                  <a:srgbClr val="121820"/>
+                  <a:srgbClr val="1A1A1A"/>
                 </a:solidFill>
                 <a:latin typeface="Calibri" pitchFamily="34" charset="0"/>
                 <a:ea typeface="Calibri" pitchFamily="34" charset="-122"/>
@@ -10466,7 +10466,7 @@
             <a:r>
               <a:rPr lang="en-US" sz="2800" b="1" dirty="0">
                 <a:solidFill>
-                  <a:srgbClr val="121820"/>
+                  <a:srgbClr val="1A1A1A"/>
                 </a:solidFill>
                 <a:latin typeface="Calibri" pitchFamily="34" charset="0"/>
                 <a:ea typeface="Calibri" pitchFamily="34" charset="-122"/>
@@ -10637,7 +10637,7 @@
             <a:r>
               <a:rPr lang="en-US" sz="2800" b="1" dirty="0">
                 <a:solidFill>
-                  <a:srgbClr val="121820"/>
+                  <a:srgbClr val="1A1A1A"/>
                 </a:solidFill>
                 <a:latin typeface="Calibri" pitchFamily="34" charset="0"/>
                 <a:ea typeface="Calibri" pitchFamily="34" charset="-122"/>
@@ -10682,7 +10682,7 @@
             <a:r>
               <a:rPr lang="en-US" sz="1600" dirty="0">
                 <a:solidFill>
-                  <a:srgbClr val="121820"/>
+                  <a:srgbClr val="1A1A1A"/>
                 </a:solidFill>
                 <a:latin typeface="Calibri" pitchFamily="34" charset="0"/>
                 <a:ea typeface="Calibri" pitchFamily="34" charset="-122"/>
@@ -10703,7 +10703,7 @@
             <a:r>
               <a:rPr lang="en-US" sz="1600" dirty="0">
                 <a:solidFill>
-                  <a:srgbClr val="121820"/>
+                  <a:srgbClr val="1A1A1A"/>
                 </a:solidFill>
                 <a:latin typeface="Calibri" pitchFamily="34" charset="0"/>
                 <a:ea typeface="Calibri" pitchFamily="34" charset="-122"/>
@@ -10724,7 +10724,7 @@
             <a:r>
               <a:rPr lang="en-US" sz="1600" dirty="0">
                 <a:solidFill>
-                  <a:srgbClr val="121820"/>
+                  <a:srgbClr val="1A1A1A"/>
                 </a:solidFill>
                 <a:latin typeface="Calibri" pitchFamily="34" charset="0"/>
                 <a:ea typeface="Calibri" pitchFamily="34" charset="-122"/>
@@ -10745,7 +10745,7 @@
             <a:r>
               <a:rPr lang="en-US" sz="1600" dirty="0">
                 <a:solidFill>
-                  <a:srgbClr val="121820"/>
+                  <a:srgbClr val="1A1A1A"/>
                 </a:solidFill>
                 <a:latin typeface="Calibri" pitchFamily="34" charset="0"/>
                 <a:ea typeface="Calibri" pitchFamily="34" charset="-122"/>
@@ -10900,7 +10900,7 @@
             <a:r>
               <a:rPr lang="en-US" sz="2800" b="1" dirty="0">
                 <a:solidFill>
-                  <a:srgbClr val="121820"/>
+                  <a:srgbClr val="1A1A1A"/>
                 </a:solidFill>
                 <a:latin typeface="Calibri" pitchFamily="34" charset="0"/>
                 <a:ea typeface="Calibri" pitchFamily="34" charset="-122"/>
@@ -10942,7 +10942,7 @@
             <a:r>
               <a:rPr lang="en-US" sz="1600" dirty="0">
                 <a:solidFill>
-                  <a:srgbClr val="121820"/>
+                  <a:srgbClr val="1A1A1A"/>
                 </a:solidFill>
                 <a:latin typeface="Calibri" pitchFamily="34" charset="0"/>
                 <a:ea typeface="Calibri" pitchFamily="34" charset="-122"/>
@@ -10972,7 +10972,7 @@
             <a:r>
               <a:rPr lang="en-US" sz="1600" dirty="0">
                 <a:solidFill>
-                  <a:srgbClr val="121820"/>
+                  <a:srgbClr val="1A1A1A"/>
                 </a:solidFill>
                 <a:latin typeface="Calibri" pitchFamily="34" charset="0"/>
                 <a:ea typeface="Calibri" pitchFamily="34" charset="-122"/>
@@ -10993,7 +10993,7 @@
             <a:r>
               <a:rPr lang="en-US" sz="1600" dirty="0">
                 <a:solidFill>
-                  <a:srgbClr val="121820"/>
+                  <a:srgbClr val="1A1A1A"/>
                 </a:solidFill>
                 <a:latin typeface="Calibri" pitchFamily="34" charset="0"/>
                 <a:ea typeface="Calibri" pitchFamily="34" charset="-122"/>
@@ -11014,7 +11014,7 @@
             <a:r>
               <a:rPr lang="en-US" sz="1600" dirty="0">
                 <a:solidFill>
-                  <a:srgbClr val="121820"/>
+                  <a:srgbClr val="1A1A1A"/>
                 </a:solidFill>
                 <a:latin typeface="Calibri" pitchFamily="34" charset="0"/>
                 <a:ea typeface="Calibri" pitchFamily="34" charset="-122"/>
@@ -11117,7 +11117,7 @@
             <a:r>
               <a:rPr lang="en-US" sz="1800" b="1" dirty="0">
                 <a:solidFill>
-                  <a:srgbClr val="121820"/>
+                  <a:srgbClr val="1A1A1A"/>
                 </a:solidFill>
                 <a:latin typeface="Calibri" pitchFamily="34" charset="0"/>
                 <a:ea typeface="Calibri" pitchFamily="34" charset="-122"/>
@@ -11345,7 +11345,7 @@
             <a:r>
               <a:rPr lang="en-US" sz="2800" b="1" dirty="0">
                 <a:solidFill>
-                  <a:srgbClr val="121820"/>
+                  <a:srgbClr val="1A1A1A"/>
                 </a:solidFill>
                 <a:latin typeface="Calibri" pitchFamily="34" charset="0"/>
                 <a:ea typeface="Calibri" pitchFamily="34" charset="-122"/>
@@ -11500,7 +11500,7 @@
             <a:r>
               <a:rPr lang="en-US" sz="2800" b="1" dirty="0">
                 <a:solidFill>
-                  <a:srgbClr val="121820"/>
+                  <a:srgbClr val="1A1A1A"/>
                 </a:solidFill>
                 <a:latin typeface="Calibri" pitchFamily="34" charset="0"/>
                 <a:ea typeface="Calibri" pitchFamily="34" charset="-122"/>
@@ -11545,7 +11545,7 @@
             <a:r>
               <a:rPr lang="en-US" sz="1600" dirty="0">
                 <a:solidFill>
-                  <a:srgbClr val="121820"/>
+                  <a:srgbClr val="1A1A1A"/>
                 </a:solidFill>
                 <a:latin typeface="Calibri" pitchFamily="34" charset="0"/>
                 <a:ea typeface="Calibri" pitchFamily="34" charset="-122"/>
@@ -11566,7 +11566,7 @@
             <a:r>
               <a:rPr lang="en-US" sz="1600" dirty="0">
                 <a:solidFill>
-                  <a:srgbClr val="121820"/>
+                  <a:srgbClr val="1A1A1A"/>
                 </a:solidFill>
                 <a:latin typeface="Calibri" pitchFamily="34" charset="0"/>
                 <a:ea typeface="Calibri" pitchFamily="34" charset="-122"/>
@@ -11587,7 +11587,7 @@
             <a:r>
               <a:rPr lang="en-US" sz="1600" dirty="0">
                 <a:solidFill>
-                  <a:srgbClr val="121820"/>
+                  <a:srgbClr val="1A1A1A"/>
                 </a:solidFill>
                 <a:latin typeface="Calibri" pitchFamily="34" charset="0"/>
                 <a:ea typeface="Calibri" pitchFamily="34" charset="-122"/>
@@ -11608,7 +11608,7 @@
             <a:r>
               <a:rPr lang="en-US" sz="1600" dirty="0">
                 <a:solidFill>
-                  <a:srgbClr val="121820"/>
+                  <a:srgbClr val="1A1A1A"/>
                 </a:solidFill>
                 <a:latin typeface="Calibri" pitchFamily="34" charset="0"/>
                 <a:ea typeface="Calibri" pitchFamily="34" charset="-122"/>
@@ -11763,7 +11763,7 @@
             <a:r>
               <a:rPr lang="en-US" sz="2800" b="1" dirty="0">
                 <a:solidFill>
-                  <a:srgbClr val="121820"/>
+                  <a:srgbClr val="1A1A1A"/>
                 </a:solidFill>
                 <a:latin typeface="Calibri" pitchFamily="34" charset="0"/>
                 <a:ea typeface="Calibri" pitchFamily="34" charset="-122"/>
@@ -11918,7 +11918,7 @@
             <a:r>
               <a:rPr lang="en-US" sz="2800" b="1" dirty="0">
                 <a:solidFill>
-                  <a:srgbClr val="121820"/>
+                  <a:srgbClr val="1A1A1A"/>
                 </a:solidFill>
                 <a:latin typeface="Calibri" pitchFamily="34" charset="0"/>
                 <a:ea typeface="Calibri" pitchFamily="34" charset="-122"/>
@@ -11963,7 +11963,7 @@
             <a:r>
               <a:rPr lang="en-US" sz="1600" dirty="0">
                 <a:solidFill>
-                  <a:srgbClr val="121820"/>
+                  <a:srgbClr val="1A1A1A"/>
                 </a:solidFill>
                 <a:latin typeface="Calibri" pitchFamily="34" charset="0"/>
                 <a:ea typeface="Calibri" pitchFamily="34" charset="-122"/>
@@ -11984,7 +11984,7 @@
             <a:r>
               <a:rPr lang="en-US" sz="1600" dirty="0">
                 <a:solidFill>
-                  <a:srgbClr val="121820"/>
+                  <a:srgbClr val="1A1A1A"/>
                 </a:solidFill>
                 <a:latin typeface="Calibri" pitchFamily="34" charset="0"/>
                 <a:ea typeface="Calibri" pitchFamily="34" charset="-122"/>
@@ -12005,7 +12005,7 @@
             <a:r>
               <a:rPr lang="en-US" sz="1600" dirty="0">
                 <a:solidFill>
-                  <a:srgbClr val="121820"/>
+                  <a:srgbClr val="1A1A1A"/>
                 </a:solidFill>
                 <a:latin typeface="Calibri" pitchFamily="34" charset="0"/>
                 <a:ea typeface="Calibri" pitchFamily="34" charset="-122"/>
@@ -12026,7 +12026,7 @@
             <a:r>
               <a:rPr lang="en-US" sz="1600" dirty="0">
                 <a:solidFill>
-                  <a:srgbClr val="121820"/>
+                  <a:srgbClr val="1A1A1A"/>
                 </a:solidFill>
                 <a:latin typeface="Calibri" pitchFamily="34" charset="0"/>
                 <a:ea typeface="Calibri" pitchFamily="34" charset="-122"/>
@@ -12181,7 +12181,7 @@
             <a:r>
               <a:rPr lang="en-US" sz="2800" b="1" dirty="0">
                 <a:solidFill>
-                  <a:srgbClr val="121820"/>
+                  <a:srgbClr val="1A1A1A"/>
                 </a:solidFill>
                 <a:latin typeface="Calibri" pitchFamily="34" charset="0"/>
                 <a:ea typeface="Calibri" pitchFamily="34" charset="-122"/>
@@ -12336,7 +12336,7 @@
             <a:r>
               <a:rPr lang="en-US" sz="3600" b="1" dirty="0">
                 <a:solidFill>
-                  <a:srgbClr val="121820"/>
+                  <a:srgbClr val="1A1A1A"/>
                 </a:solidFill>
                 <a:latin typeface="Calibri" pitchFamily="34" charset="0"/>
                 <a:ea typeface="Calibri" pitchFamily="34" charset="-122"/>
@@ -12566,7 +12566,7 @@
             <a:r>
               <a:rPr lang="en-US" sz="2800" b="1" dirty="0">
                 <a:solidFill>
-                  <a:srgbClr val="121820"/>
+                  <a:srgbClr val="1A1A1A"/>
                 </a:solidFill>
                 <a:latin typeface="Calibri" pitchFamily="34" charset="0"/>
                 <a:ea typeface="Calibri" pitchFamily="34" charset="-122"/>
@@ -12611,7 +12611,7 @@
             <a:r>
               <a:rPr lang="en-US" sz="1600" dirty="0">
                 <a:solidFill>
-                  <a:srgbClr val="121820"/>
+                  <a:srgbClr val="1A1A1A"/>
                 </a:solidFill>
                 <a:latin typeface="Calibri" pitchFamily="34" charset="0"/>
                 <a:ea typeface="Calibri" pitchFamily="34" charset="-122"/>
@@ -12632,7 +12632,7 @@
             <a:r>
               <a:rPr lang="en-US" sz="1600" dirty="0">
                 <a:solidFill>
-                  <a:srgbClr val="121820"/>
+                  <a:srgbClr val="1A1A1A"/>
                 </a:solidFill>
                 <a:latin typeface="Calibri" pitchFamily="34" charset="0"/>
                 <a:ea typeface="Calibri" pitchFamily="34" charset="-122"/>
@@ -12653,7 +12653,7 @@
             <a:r>
               <a:rPr lang="en-US" sz="1600" dirty="0">
                 <a:solidFill>
-                  <a:srgbClr val="121820"/>
+                  <a:srgbClr val="1A1A1A"/>
                 </a:solidFill>
                 <a:latin typeface="Calibri" pitchFamily="34" charset="0"/>
                 <a:ea typeface="Calibri" pitchFamily="34" charset="-122"/>
@@ -12674,7 +12674,7 @@
             <a:r>
               <a:rPr lang="en-US" sz="1600" dirty="0">
                 <a:solidFill>
-                  <a:srgbClr val="121820"/>
+                  <a:srgbClr val="1A1A1A"/>
                 </a:solidFill>
                 <a:latin typeface="Calibri" pitchFamily="34" charset="0"/>
                 <a:ea typeface="Calibri" pitchFamily="34" charset="-122"/>
@@ -13708,7 +13708,7 @@
             <a:r>
               <a:rPr lang="en-US" sz="4800" b="1" dirty="0">
                 <a:solidFill>
-                  <a:srgbClr val="121820"/>
+                  <a:srgbClr val="1A1A1A"/>
                 </a:solidFill>
                 <a:latin typeface="Calibri" pitchFamily="34" charset="0"/>
                 <a:ea typeface="Calibri" pitchFamily="34" charset="-122"/>
@@ -13945,7 +13945,7 @@
             <a:r>
               <a:rPr lang="en-US" sz="3600" b="1" dirty="0">
                 <a:solidFill>
-                  <a:srgbClr val="121820"/>
+                  <a:srgbClr val="1A1A1A"/>
                 </a:solidFill>
                 <a:latin typeface="Calibri" pitchFamily="34" charset="0"/>
                 <a:ea typeface="Calibri" pitchFamily="34" charset="-122"/>
@@ -14100,7 +14100,7 @@
             <a:r>
               <a:rPr lang="en-US" sz="4800" b="1" dirty="0">
                 <a:solidFill>
-                  <a:srgbClr val="121820"/>
+                  <a:srgbClr val="1A1A1A"/>
                 </a:solidFill>
                 <a:latin typeface="Calibri" pitchFamily="34" charset="0"/>
                 <a:ea typeface="Calibri" pitchFamily="34" charset="-122"/>

</xml_diff>

<commit_message>
Add the Monthly Business Review deck on the shared CTS masters
Moves the 19 layouts into cts_masters.js so every deck builds from one
definition, then adds presentation/mbr: a data-driven review deck with
P&L summary, P&L per department, risk revenue profile, top 10 customers,
DSO and receivables, top customers year on year, utilisation, profit
based on utilisation and an actions table, each with a commentary panel.
Figures in mbr_data.json are illustrative placeholders.

Co-Authored-By: Claude Fable 5.1 <noreply@anthropic.com>
Claude-Session: https://claude.ai/code/session_01XrzJEmFyMntLmpxLDC4vTY
</commit_message>
<xml_diff>
--- a/presentation/CTS Presentation Template.pptx
+++ b/presentation/CTS Presentation Template.pptx
@@ -1105,7 +1105,7 @@
           <a:p>
             <a:r>
               <a:rPr lang="en-US" dirty="0"/>
-              <a:t>CTS Cover (dark). Black background, CTS Seamless AV logo, the three division colours as the motif.</a:t>
+              <a:t>CTS Cover (dark). Charcoal background, CTS Seamless AV logo, the three division colours as the motif.</a:t>
             </a:r>
             <a:endParaRPr lang="en-US" dirty="0"/>
           </a:p>
@@ -2073,7 +2073,7 @@
           <a:p>
             <a:r>
               <a:rPr lang="en-US" dirty="0"/>
-              <a:t>CTS Cover (light). White with a black panel.</a:t>
+              <a:t>CTS Cover (light). White with a charcoal panel.</a:t>
             </a:r>
             <a:endParaRPr lang="en-US" dirty="0"/>
           </a:p>
@@ -2337,7 +2337,7 @@
           <a:p>
             <a:r>
               <a:rPr lang="en-US" dirty="0"/>
-              <a:t>CTS Production cover. Black background with the Production lock-up and mint and teal circles.</a:t>
+              <a:t>CTS Production cover. Charcoal background with the Production lock-up and mint and teal circles.</a:t>
             </a:r>
             <a:endParaRPr lang="en-US" dirty="0"/>
           </a:p>
@@ -2425,7 +2425,7 @@
           <a:p>
             <a:r>
               <a:rPr lang="en-US" dirty="0"/>
-              <a:t>CTS Consulting cover. Black background with the Consulting lock-up and lavender and navy circles.</a:t>
+              <a:t>CTS Consulting cover. Charcoal background with the Consulting lock-up and lavender and navy circles.</a:t>
             </a:r>
             <a:endParaRPr lang="en-US" dirty="0"/>
           </a:p>
@@ -2513,7 +2513,7 @@
           <a:p>
             <a:r>
               <a:rPr lang="en-US" dirty="0"/>
-              <a:t>CTS Support cover. Black background with the Support lock-up and rose and burgundy circles.</a:t>
+              <a:t>CTS Support cover. Charcoal background with the Support lock-up and rose and burgundy circles.</a:t>
             </a:r>
             <a:endParaRPr lang="en-US" dirty="0"/>
           </a:p>

</xml_diff>